<commit_message>
Prepare cleaner materials and a verified local transfer
</commit_message>
<xml_diff>
--- a/docs/presentation/minimax-depth3/Minimax_Depth3_Example.pptx
+++ b/docs/presentation/minimax-depth3/Minimax_Depth3_Example.pptx
@@ -503,7 +503,7 @@
           <a:lstStyle/>
           <a:p>
             <a:r>
-              <a:t>Depth 3 counts the first BOT move simulated in findBestMove, followed by two recursive moves. Every score is from the BOT perspective. Begin with the eight bottom scores. The last BOT calls return MAX values 6,3,9,0. The HUMAN calls return MIN values 3 for A and 0 for B. findBestMove compares those returned values and returns move A. Follow the gold path A/H2/Reply2, but explain that only A is executed now. The other moves are simulated on copied Game objects. Illustrative material scores, not a legal-board trace. Assumes alternating turns and no earlier winner. In actual capture chains the same player may continue; game.getCurrentPlayer() determines MIN/MAX. Alpha-beta causes no cutoffs with these values and this move order.</a:t>
+              <a:t>Depth 3 counts the first BOT move simulated in findBestMove, followed by two recursive moves. Every score is from the BOT perspective. Begin with the eight bottom scores. The last BOT calls return MAX values 6, 3, 9, 0. The HUMAN calls return MIN values 3 for A and 0 for B. findBestMove compares those returned values and returns move A. Follow the gold path A/H2/Reply2, but explain that only A is executed now. The other moves are simulated on copied Game objects. Illustrative material scores, not a legal-board trace. Assumes alternating turns and no earlier winner. In actual capture chains the same player may continue; game.getCurrentPlayer() determines MIN/MAX. Alpha-beta causes no cutoffs with these values and this move order.</a:t>
             </a:r>
           </a:p>
         </p:txBody>
@@ -573,7 +573,7 @@
           <a:lstStyle/>
           <a:p>
             <a:r>
-              <a:t>Use this table to show each complete three-move path separately. Reply1/Reply2 name local options within their own branch. Scores are evaluated at depth0, rather than added along the path. For A: final BOT calls return6 and3; HUMAN returns3. For B: final BOT calls return9 and0; HUMAN returns0. The wrapper findBestMove tracks bestScore and bestMove and returns A because3&gt;0.</a:t>
+              <a:t>Use this table to show each complete three-move path separately. Reply 1/Reply 2 name local options within their own branch. Scores are evaluated at depth 0, rather than added along the path. For A: final BOT calls return 6 and 3; HUMAN returns 3. For B: final BOT calls return 9 and 0; HUMAN returns 0. The wrapper findBestMove tracks bestScore and bestMove and returns A because 3 &gt; 0.</a:t>
             </a:r>
           </a:p>
         </p:txBody>
@@ -3595,8 +3595,8 @@
         </p:nvSpPr>
         <p:spPr>
           <a:xfrm>
-            <a:off x="594360" y="210312"/>
-            <a:ext cx="10972800" cy="201168"/>
+            <a:off x="548640" y="329184"/>
+            <a:ext cx="13533120" cy="585216"/>
           </a:xfrm>
           <a:prstGeom prst="rect">
             <a:avLst/>
@@ -3609,110 +3609,39 @@
           </a:bodyPr>
           <a:lstStyle/>
           <a:p>
-            <a:pPr algn="l">
-              <a:defRPr sz="1300" b="1">
-                <a:solidFill>
-                  <a:srgbClr val="245B43"/>
+            <a:pPr algn="ctr">
+              <a:defRPr sz="3400" b="1">
+                <a:solidFill>
+                  <a:srgbClr val="17382D"/>
                 </a:solidFill>
                 <a:latin typeface="Arial"/>
               </a:defRPr>
             </a:pPr>
             <a:r>
-              <a:t>DAMKA  /  HOW THE BOT CHOOSES A MOVE</a:t>
-            </a:r>
-          </a:p>
-        </p:txBody>
-      </p:sp>
-      <p:sp>
-        <p:nvSpPr>
-          <p:cNvPr id="3" name="TextBox 2"/>
-          <p:cNvSpPr txBox="1"/>
-          <p:nvPr/>
-        </p:nvSpPr>
-        <p:spPr>
-          <a:xfrm>
-            <a:off x="594360" y="603504"/>
-            <a:ext cx="13441680" cy="512064"/>
-          </a:xfrm>
-          <a:prstGeom prst="rect">
-            <a:avLst/>
-          </a:prstGeom>
-          <a:noFill/>
-        </p:spPr>
-        <p:txBody>
-          <a:bodyPr wrap="none" lIns="0" rIns="0" tIns="0" bIns="0" anchor="ctr">
-            <a:spAutoFit/>
-          </a:bodyPr>
-          <a:lstStyle/>
-          <a:p>
-            <a:pPr algn="l">
-              <a:defRPr sz="3300" b="1">
-                <a:solidFill>
-                  <a:srgbClr val="17382D"/>
-                </a:solidFill>
-                <a:latin typeface="Arial"/>
-              </a:defRPr>
-            </a:pPr>
-            <a:r>
-              <a:t>Minimax: three moves ahead</a:t>
-            </a:r>
-          </a:p>
-        </p:txBody>
-      </p:sp>
-      <p:sp>
-        <p:nvSpPr>
-          <p:cNvPr id="4" name="TextBox 3"/>
-          <p:cNvSpPr txBox="1"/>
-          <p:nvPr/>
-        </p:nvSpPr>
-        <p:spPr>
-          <a:xfrm>
-            <a:off x="594360" y="1197864"/>
-            <a:ext cx="13441680" cy="329184"/>
-          </a:xfrm>
-          <a:prstGeom prst="rect">
-            <a:avLst/>
-          </a:prstGeom>
-          <a:noFill/>
-        </p:spPr>
-        <p:txBody>
-          <a:bodyPr wrap="none" lIns="0" rIns="0" tIns="0" bIns="0" anchor="ctr">
-            <a:spAutoFit/>
-          </a:bodyPr>
-          <a:lstStyle/>
-          <a:p>
-            <a:pPr algn="l">
-              <a:defRPr sz="1900" b="0">
-                <a:solidFill>
-                  <a:srgbClr val="53665D"/>
-                </a:solidFill>
-                <a:latin typeface="Arial"/>
-              </a:defRPr>
-            </a:pPr>
-            <a:r>
-              <a:t>Explore BOT → HUMAN → BOT. Then return the scores upward to choose the first move.</a:t>
+              <a:t>Minimax · Depth 3</a:t>
             </a:r>
           </a:p>
         </p:txBody>
       </p:sp>
       <p:cxnSp>
         <p:nvCxnSpPr>
-          <p:cNvPr id="5" name="Connector 4"/>
+          <p:cNvPr id="3" name="Connector 2"/>
           <p:cNvCxnSpPr/>
           <p:nvPr/>
         </p:nvCxnSpPr>
         <p:spPr>
-          <a:xfrm>
-            <a:off x="594360" y="1645920"/>
-            <a:ext cx="13441680" cy="0"/>
+          <a:xfrm flipV="1">
+            <a:off x="3749039" y="2404872"/>
+            <a:ext cx="2834641" cy="777240"/>
           </a:xfrm>
           <a:prstGeom prst="line">
             <a:avLst/>
           </a:prstGeom>
-          <a:ln w="12700">
+          <a:ln w="38100">
             <a:solidFill>
-              <a:srgbClr val="C9D4CC"/>
+              <a:srgbClr val="936600"/>
             </a:solidFill>
+            <a:tailEnd type="triangle"/>
           </a:ln>
         </p:spPr>
         <p:style>
@@ -3730,78 +3659,150 @@
           </a:fontRef>
         </p:style>
       </p:cxnSp>
-      <p:sp>
-        <p:nvSpPr>
-          <p:cNvPr id="6" name="TextBox 5"/>
-          <p:cNvSpPr txBox="1"/>
-          <p:nvPr/>
-        </p:nvSpPr>
-        <p:spPr>
-          <a:xfrm>
-            <a:off x="594360" y="7818120"/>
-            <a:ext cx="12527280" cy="201168"/>
-          </a:xfrm>
-          <a:prstGeom prst="rect">
-            <a:avLst/>
-          </a:prstGeom>
-          <a:noFill/>
-        </p:spPr>
-        <p:txBody>
-          <a:bodyPr wrap="none" lIns="0" rIns="0" tIns="0" bIns="0" anchor="ctr">
-            <a:spAutoFit/>
-          </a:bodyPr>
-          <a:lstStyle/>
-          <a:p>
-            <a:pPr algn="l">
-              <a:defRPr sz="1300" b="0">
-                <a:solidFill>
-                  <a:srgbClr val="53665D"/>
-                </a:solidFill>
-                <a:latin typeface="Arial"/>
-              </a:defRPr>
-            </a:pPr>
-            <a:r>
-              <a:t>Illustrative scores; alternating turns and no early winner. Every score is from the BOT’s perspective.</a:t>
-            </a:r>
-          </a:p>
-        </p:txBody>
-      </p:sp>
-      <p:sp>
-        <p:nvSpPr>
-          <p:cNvPr id="7" name="TextBox 6"/>
-          <p:cNvSpPr txBox="1"/>
-          <p:nvPr/>
-        </p:nvSpPr>
-        <p:spPr>
-          <a:xfrm>
-            <a:off x="13167360" y="7799831"/>
-            <a:ext cx="868680" cy="228600"/>
-          </a:xfrm>
-          <a:prstGeom prst="rect">
-            <a:avLst/>
-          </a:prstGeom>
-          <a:noFill/>
-        </p:spPr>
-        <p:txBody>
-          <a:bodyPr wrap="none" lIns="0" rIns="0" tIns="0" bIns="0" anchor="ctr">
-            <a:spAutoFit/>
-          </a:bodyPr>
-          <a:lstStyle/>
-          <a:p>
-            <a:pPr algn="r">
-              <a:defRPr sz="1300" b="0">
-                <a:solidFill>
-                  <a:srgbClr val="53665D"/>
-                </a:solidFill>
-                <a:latin typeface="Arial"/>
-              </a:defRPr>
-            </a:pPr>
-            <a:r>
-              <a:t>01 / 02</a:t>
-            </a:r>
-          </a:p>
-        </p:txBody>
-      </p:sp>
+      <p:cxnSp>
+        <p:nvCxnSpPr>
+          <p:cNvPr id="4" name="Connector 3"/>
+          <p:cNvCxnSpPr/>
+          <p:nvPr/>
+        </p:nvCxnSpPr>
+        <p:spPr>
+          <a:xfrm flipV="1">
+            <a:off x="1965960" y="4233672"/>
+            <a:ext cx="1188719" cy="868680"/>
+          </a:xfrm>
+          <a:prstGeom prst="line">
+            <a:avLst/>
+          </a:prstGeom>
+          <a:ln w="22860">
+            <a:solidFill>
+              <a:srgbClr val="C9D4CC"/>
+            </a:solidFill>
+            <a:tailEnd type="triangle"/>
+          </a:ln>
+        </p:spPr>
+        <p:style>
+          <a:lnRef idx="2">
+            <a:schemeClr val="accent1"/>
+          </a:lnRef>
+          <a:fillRef idx="0">
+            <a:schemeClr val="accent1"/>
+          </a:fillRef>
+          <a:effectRef idx="1">
+            <a:schemeClr val="accent1"/>
+          </a:effectRef>
+          <a:fontRef idx="minor">
+            <a:schemeClr val="tx1"/>
+          </a:fontRef>
+        </p:style>
+      </p:cxnSp>
+      <p:cxnSp>
+        <p:nvCxnSpPr>
+          <p:cNvPr id="5" name="Connector 4"/>
+          <p:cNvCxnSpPr/>
+          <p:nvPr/>
+        </p:nvCxnSpPr>
+        <p:spPr>
+          <a:xfrm flipV="1">
+            <a:off x="1188719" y="6153912"/>
+            <a:ext cx="384049" cy="868680"/>
+          </a:xfrm>
+          <a:prstGeom prst="line">
+            <a:avLst/>
+          </a:prstGeom>
+          <a:ln w="22860">
+            <a:solidFill>
+              <a:srgbClr val="C9D4CC"/>
+            </a:solidFill>
+            <a:tailEnd type="triangle"/>
+          </a:ln>
+        </p:spPr>
+        <p:style>
+          <a:lnRef idx="2">
+            <a:schemeClr val="accent1"/>
+          </a:lnRef>
+          <a:fillRef idx="0">
+            <a:schemeClr val="accent1"/>
+          </a:fillRef>
+          <a:effectRef idx="1">
+            <a:schemeClr val="accent1"/>
+          </a:effectRef>
+          <a:fontRef idx="minor">
+            <a:schemeClr val="tx1"/>
+          </a:fontRef>
+        </p:style>
+      </p:cxnSp>
+      <p:cxnSp>
+        <p:nvCxnSpPr>
+          <p:cNvPr id="6" name="Connector 5"/>
+          <p:cNvCxnSpPr/>
+          <p:nvPr/>
+        </p:nvCxnSpPr>
+        <p:spPr>
+          <a:xfrm flipH="1" flipV="1">
+            <a:off x="2359152" y="6153912"/>
+            <a:ext cx="384048" cy="868680"/>
+          </a:xfrm>
+          <a:prstGeom prst="line">
+            <a:avLst/>
+          </a:prstGeom>
+          <a:ln w="22860">
+            <a:solidFill>
+              <a:srgbClr val="C9D4CC"/>
+            </a:solidFill>
+            <a:tailEnd type="triangle"/>
+          </a:ln>
+        </p:spPr>
+        <p:style>
+          <a:lnRef idx="2">
+            <a:schemeClr val="accent1"/>
+          </a:lnRef>
+          <a:fillRef idx="0">
+            <a:schemeClr val="accent1"/>
+          </a:fillRef>
+          <a:effectRef idx="1">
+            <a:schemeClr val="accent1"/>
+          </a:effectRef>
+          <a:fontRef idx="minor">
+            <a:schemeClr val="tx1"/>
+          </a:fontRef>
+        </p:style>
+      </p:cxnSp>
+      <p:cxnSp>
+        <p:nvCxnSpPr>
+          <p:cNvPr id="7" name="Connector 6"/>
+          <p:cNvCxnSpPr/>
+          <p:nvPr/>
+        </p:nvCxnSpPr>
+        <p:spPr>
+          <a:xfrm flipH="1" flipV="1">
+            <a:off x="4343400" y="4233672"/>
+            <a:ext cx="1188720" cy="868680"/>
+          </a:xfrm>
+          <a:prstGeom prst="line">
+            <a:avLst/>
+          </a:prstGeom>
+          <a:ln w="38100">
+            <a:solidFill>
+              <a:srgbClr val="936600"/>
+            </a:solidFill>
+            <a:tailEnd type="triangle"/>
+          </a:ln>
+        </p:spPr>
+        <p:style>
+          <a:lnRef idx="2">
+            <a:schemeClr val="accent1"/>
+          </a:lnRef>
+          <a:fillRef idx="0">
+            <a:schemeClr val="accent1"/>
+          </a:fillRef>
+          <a:effectRef idx="1">
+            <a:schemeClr val="accent1"/>
+          </a:effectRef>
+          <a:fontRef idx="minor">
+            <a:schemeClr val="tx1"/>
+          </a:fontRef>
+        </p:style>
+      </p:cxnSp>
       <p:cxnSp>
         <p:nvCxnSpPr>
           <p:cNvPr id="8" name="Connector 7"/>
@@ -3810,15 +3811,15 @@
         </p:nvCxnSpPr>
         <p:spPr>
           <a:xfrm flipV="1">
-            <a:off x="4846320" y="2615184"/>
-            <a:ext cx="2514600" cy="448056"/>
+            <a:off x="4754880" y="6153912"/>
+            <a:ext cx="384048" cy="868680"/>
           </a:xfrm>
           <a:prstGeom prst="line">
             <a:avLst/>
           </a:prstGeom>
-          <a:ln w="38100">
+          <a:ln w="22860">
             <a:solidFill>
-              <a:srgbClr val="936600"/>
+              <a:srgbClr val="C9D4CC"/>
             </a:solidFill>
             <a:tailEnd type="triangle"/>
           </a:ln>
@@ -3845,16 +3846,16 @@
           <p:nvPr/>
         </p:nvCxnSpPr>
         <p:spPr>
-          <a:xfrm flipV="1">
-            <a:off x="3291840" y="3867912"/>
-            <a:ext cx="1115568" cy="539496"/>
+          <a:xfrm flipH="1" flipV="1">
+            <a:off x="5925312" y="6153912"/>
+            <a:ext cx="384047" cy="868680"/>
           </a:xfrm>
           <a:prstGeom prst="line">
             <a:avLst/>
           </a:prstGeom>
-          <a:ln w="22860">
+          <a:ln w="38100">
             <a:solidFill>
-              <a:srgbClr val="C9D4CC"/>
+              <a:srgbClr val="936600"/>
             </a:solidFill>
             <a:tailEnd type="triangle"/>
           </a:ln>
@@ -3881,9 +3882,9 @@
           <p:nvPr/>
         </p:nvCxnSpPr>
         <p:spPr>
-          <a:xfrm flipV="1">
-            <a:off x="2697480" y="5212080"/>
-            <a:ext cx="301752" cy="530352"/>
+          <a:xfrm flipH="1" flipV="1">
+            <a:off x="8046720" y="2404872"/>
+            <a:ext cx="2834640" cy="777240"/>
           </a:xfrm>
           <a:prstGeom prst="line">
             <a:avLst/>
@@ -3917,9 +3918,9 @@
           <p:nvPr/>
         </p:nvCxnSpPr>
         <p:spPr>
-          <a:xfrm flipH="1" flipV="1">
-            <a:off x="3584448" y="5212080"/>
-            <a:ext cx="301752" cy="530352"/>
+          <a:xfrm flipV="1">
+            <a:off x="9098280" y="4233672"/>
+            <a:ext cx="1188720" cy="868680"/>
           </a:xfrm>
           <a:prstGeom prst="line">
             <a:avLst/>
@@ -3953,16 +3954,16 @@
           <p:nvPr/>
         </p:nvCxnSpPr>
         <p:spPr>
-          <a:xfrm flipH="1" flipV="1">
-            <a:off x="5285231" y="3867912"/>
-            <a:ext cx="1115569" cy="539496"/>
+          <a:xfrm flipV="1">
+            <a:off x="8321040" y="6153912"/>
+            <a:ext cx="384048" cy="868680"/>
           </a:xfrm>
           <a:prstGeom prst="line">
             <a:avLst/>
           </a:prstGeom>
-          <a:ln w="38100">
+          <a:ln w="22860">
             <a:solidFill>
-              <a:srgbClr val="936600"/>
+              <a:srgbClr val="C9D4CC"/>
             </a:solidFill>
             <a:tailEnd type="triangle"/>
           </a:ln>
@@ -3989,9 +3990,9 @@
           <p:nvPr/>
         </p:nvCxnSpPr>
         <p:spPr>
-          <a:xfrm flipV="1">
-            <a:off x="5806440" y="5212080"/>
-            <a:ext cx="301752" cy="530352"/>
+          <a:xfrm flipH="1" flipV="1">
+            <a:off x="9491472" y="6153912"/>
+            <a:ext cx="384047" cy="868680"/>
           </a:xfrm>
           <a:prstGeom prst="line">
             <a:avLst/>
@@ -4026,15 +4027,15 @@
         </p:nvCxnSpPr>
         <p:spPr>
           <a:xfrm flipH="1" flipV="1">
-            <a:off x="6693408" y="5212080"/>
-            <a:ext cx="301752" cy="530352"/>
+            <a:off x="11475720" y="4233672"/>
+            <a:ext cx="1188720" cy="868680"/>
           </a:xfrm>
           <a:prstGeom prst="line">
             <a:avLst/>
           </a:prstGeom>
-          <a:ln w="38100">
+          <a:ln w="22860">
             <a:solidFill>
-              <a:srgbClr val="936600"/>
+              <a:srgbClr val="C9D4CC"/>
             </a:solidFill>
             <a:tailEnd type="triangle"/>
           </a:ln>
@@ -4061,9 +4062,9 @@
           <p:nvPr/>
         </p:nvCxnSpPr>
         <p:spPr>
-          <a:xfrm flipH="1" flipV="1">
-            <a:off x="8549640" y="2615184"/>
-            <a:ext cx="2514600" cy="448056"/>
+          <a:xfrm flipV="1">
+            <a:off x="11887200" y="6153912"/>
+            <a:ext cx="384048" cy="868680"/>
           </a:xfrm>
           <a:prstGeom prst="line">
             <a:avLst/>
@@ -4097,9 +4098,9 @@
           <p:nvPr/>
         </p:nvCxnSpPr>
         <p:spPr>
-          <a:xfrm flipV="1">
-            <a:off x="9509760" y="3867912"/>
-            <a:ext cx="1115568" cy="539496"/>
+          <a:xfrm flipH="1" flipV="1">
+            <a:off x="13057632" y="6153912"/>
+            <a:ext cx="384048" cy="868680"/>
           </a:xfrm>
           <a:prstGeom prst="line">
             <a:avLst/>
@@ -4126,772 +4127,16 @@
           </a:fontRef>
         </p:style>
       </p:cxnSp>
-      <p:cxnSp>
-        <p:nvCxnSpPr>
-          <p:cNvPr id="17" name="Connector 16"/>
-          <p:cNvCxnSpPr/>
-          <p:nvPr/>
-        </p:nvCxnSpPr>
-        <p:spPr>
-          <a:xfrm flipV="1">
-            <a:off x="8915400" y="5212080"/>
-            <a:ext cx="301752" cy="530352"/>
-          </a:xfrm>
-          <a:prstGeom prst="line">
-            <a:avLst/>
-          </a:prstGeom>
-          <a:ln w="22860">
-            <a:solidFill>
-              <a:srgbClr val="C9D4CC"/>
-            </a:solidFill>
-            <a:tailEnd type="triangle"/>
-          </a:ln>
-        </p:spPr>
-        <p:style>
-          <a:lnRef idx="2">
-            <a:schemeClr val="accent1"/>
-          </a:lnRef>
-          <a:fillRef idx="0">
-            <a:schemeClr val="accent1"/>
-          </a:fillRef>
-          <a:effectRef idx="1">
-            <a:schemeClr val="accent1"/>
-          </a:effectRef>
-          <a:fontRef idx="minor">
-            <a:schemeClr val="tx1"/>
-          </a:fontRef>
-        </p:style>
-      </p:cxnSp>
-      <p:cxnSp>
-        <p:nvCxnSpPr>
-          <p:cNvPr id="18" name="Connector 17"/>
-          <p:cNvCxnSpPr/>
-          <p:nvPr/>
-        </p:nvCxnSpPr>
-        <p:spPr>
-          <a:xfrm flipH="1" flipV="1">
-            <a:off x="9802368" y="5212080"/>
-            <a:ext cx="301752" cy="530352"/>
-          </a:xfrm>
-          <a:prstGeom prst="line">
-            <a:avLst/>
-          </a:prstGeom>
-          <a:ln w="22860">
-            <a:solidFill>
-              <a:srgbClr val="C9D4CC"/>
-            </a:solidFill>
-            <a:tailEnd type="triangle"/>
-          </a:ln>
-        </p:spPr>
-        <p:style>
-          <a:lnRef idx="2">
-            <a:schemeClr val="accent1"/>
-          </a:lnRef>
-          <a:fillRef idx="0">
-            <a:schemeClr val="accent1"/>
-          </a:fillRef>
-          <a:effectRef idx="1">
-            <a:schemeClr val="accent1"/>
-          </a:effectRef>
-          <a:fontRef idx="minor">
-            <a:schemeClr val="tx1"/>
-          </a:fontRef>
-        </p:style>
-      </p:cxnSp>
-      <p:cxnSp>
-        <p:nvCxnSpPr>
-          <p:cNvPr id="19" name="Connector 18"/>
-          <p:cNvCxnSpPr/>
-          <p:nvPr/>
-        </p:nvCxnSpPr>
-        <p:spPr>
-          <a:xfrm flipH="1" flipV="1">
-            <a:off x="11503152" y="3867912"/>
-            <a:ext cx="1115568" cy="539496"/>
-          </a:xfrm>
-          <a:prstGeom prst="line">
-            <a:avLst/>
-          </a:prstGeom>
-          <a:ln w="22860">
-            <a:solidFill>
-              <a:srgbClr val="C9D4CC"/>
-            </a:solidFill>
-            <a:tailEnd type="triangle"/>
-          </a:ln>
-        </p:spPr>
-        <p:style>
-          <a:lnRef idx="2">
-            <a:schemeClr val="accent1"/>
-          </a:lnRef>
-          <a:fillRef idx="0">
-            <a:schemeClr val="accent1"/>
-          </a:fillRef>
-          <a:effectRef idx="1">
-            <a:schemeClr val="accent1"/>
-          </a:effectRef>
-          <a:fontRef idx="minor">
-            <a:schemeClr val="tx1"/>
-          </a:fontRef>
-        </p:style>
-      </p:cxnSp>
-      <p:cxnSp>
-        <p:nvCxnSpPr>
-          <p:cNvPr id="20" name="Connector 19"/>
-          <p:cNvCxnSpPr/>
-          <p:nvPr/>
-        </p:nvCxnSpPr>
-        <p:spPr>
-          <a:xfrm flipV="1">
-            <a:off x="12024360" y="5212080"/>
-            <a:ext cx="301752" cy="530352"/>
-          </a:xfrm>
-          <a:prstGeom prst="line">
-            <a:avLst/>
-          </a:prstGeom>
-          <a:ln w="22860">
-            <a:solidFill>
-              <a:srgbClr val="C9D4CC"/>
-            </a:solidFill>
-            <a:tailEnd type="triangle"/>
-          </a:ln>
-        </p:spPr>
-        <p:style>
-          <a:lnRef idx="2">
-            <a:schemeClr val="accent1"/>
-          </a:lnRef>
-          <a:fillRef idx="0">
-            <a:schemeClr val="accent1"/>
-          </a:fillRef>
-          <a:effectRef idx="1">
-            <a:schemeClr val="accent1"/>
-          </a:effectRef>
-          <a:fontRef idx="minor">
-            <a:schemeClr val="tx1"/>
-          </a:fontRef>
-        </p:style>
-      </p:cxnSp>
-      <p:cxnSp>
-        <p:nvCxnSpPr>
-          <p:cNvPr id="21" name="Connector 20"/>
-          <p:cNvCxnSpPr/>
-          <p:nvPr/>
-        </p:nvCxnSpPr>
-        <p:spPr>
-          <a:xfrm flipH="1" flipV="1">
-            <a:off x="12911328" y="5212080"/>
-            <a:ext cx="301752" cy="530352"/>
-          </a:xfrm>
-          <a:prstGeom prst="line">
-            <a:avLst/>
-          </a:prstGeom>
-          <a:ln w="22860">
-            <a:solidFill>
-              <a:srgbClr val="C9D4CC"/>
-            </a:solidFill>
-            <a:tailEnd type="triangle"/>
-          </a:ln>
-        </p:spPr>
-        <p:style>
-          <a:lnRef idx="2">
-            <a:schemeClr val="accent1"/>
-          </a:lnRef>
-          <a:fillRef idx="0">
-            <a:schemeClr val="accent1"/>
-          </a:fillRef>
-          <a:effectRef idx="1">
-            <a:schemeClr val="accent1"/>
-          </a:effectRef>
-          <a:fontRef idx="minor">
-            <a:schemeClr val="tx1"/>
-          </a:fontRef>
-        </p:style>
-      </p:cxnSp>
-      <p:sp>
-        <p:nvSpPr>
-          <p:cNvPr id="22" name="TextBox 21"/>
-          <p:cNvSpPr txBox="1"/>
-          <p:nvPr/>
-        </p:nvSpPr>
-        <p:spPr>
-          <a:xfrm>
-            <a:off x="594360" y="1837943"/>
-            <a:ext cx="1389888" cy="283464"/>
-          </a:xfrm>
-          <a:prstGeom prst="rect">
-            <a:avLst/>
-          </a:prstGeom>
-          <a:noFill/>
-        </p:spPr>
-        <p:txBody>
-          <a:bodyPr wrap="none" lIns="0" rIns="0" tIns="0" bIns="0" anchor="ctr">
-            <a:spAutoFit/>
-          </a:bodyPr>
-          <a:lstStyle/>
-          <a:p>
-            <a:pPr algn="l">
-              <a:defRPr sz="2200" b="1">
-                <a:solidFill>
-                  <a:srgbClr val="9D3E32"/>
-                </a:solidFill>
-                <a:latin typeface="Arial"/>
-              </a:defRPr>
-            </a:pPr>
-            <a:r>
-              <a:t>1  BOT</a:t>
-            </a:r>
-          </a:p>
-        </p:txBody>
-      </p:sp>
-      <p:sp>
-        <p:nvSpPr>
-          <p:cNvPr id="23" name="TextBox 22"/>
-          <p:cNvSpPr txBox="1"/>
-          <p:nvPr/>
-        </p:nvSpPr>
-        <p:spPr>
-          <a:xfrm>
-            <a:off x="594360" y="2157984"/>
-            <a:ext cx="1389888" cy="228600"/>
-          </a:xfrm>
-          <a:prstGeom prst="rect">
-            <a:avLst/>
-          </a:prstGeom>
-          <a:noFill/>
-        </p:spPr>
-        <p:txBody>
-          <a:bodyPr wrap="none" lIns="0" rIns="0" tIns="0" bIns="0" anchor="ctr">
-            <a:spAutoFit/>
-          </a:bodyPr>
-          <a:lstStyle/>
-          <a:p>
-            <a:pPr algn="l">
-              <a:defRPr sz="1800" b="1">
-                <a:solidFill>
-                  <a:srgbClr val="9D3E32"/>
-                </a:solidFill>
-                <a:latin typeface="Arial"/>
-              </a:defRPr>
-            </a:pPr>
-            <a:r>
-              <a:t>MAX</a:t>
-            </a:r>
-          </a:p>
-        </p:txBody>
-      </p:sp>
-      <p:sp>
-        <p:nvSpPr>
-          <p:cNvPr id="24" name="TextBox 23"/>
-          <p:cNvSpPr txBox="1"/>
-          <p:nvPr/>
-        </p:nvSpPr>
-        <p:spPr>
-          <a:xfrm>
-            <a:off x="594360" y="2441448"/>
-            <a:ext cx="1389888" cy="201168"/>
-          </a:xfrm>
-          <a:prstGeom prst="rect">
-            <a:avLst/>
-          </a:prstGeom>
-          <a:noFill/>
-        </p:spPr>
-        <p:txBody>
-          <a:bodyPr wrap="none" lIns="0" rIns="0" tIns="0" bIns="0" anchor="ctr">
-            <a:spAutoFit/>
-          </a:bodyPr>
-          <a:lstStyle/>
-          <a:p>
-            <a:pPr algn="l">
-              <a:defRPr sz="1400" b="0">
-                <a:solidFill>
-                  <a:srgbClr val="53665D"/>
-                </a:solidFill>
-                <a:latin typeface="Arial"/>
-              </a:defRPr>
-            </a:pPr>
-            <a:r>
-              <a:t>findBestMove()</a:t>
-            </a:r>
-          </a:p>
-        </p:txBody>
-      </p:sp>
-      <p:sp>
-        <p:nvSpPr>
-          <p:cNvPr id="25" name="TextBox 24"/>
-          <p:cNvSpPr txBox="1"/>
-          <p:nvPr/>
-        </p:nvSpPr>
-        <p:spPr>
-          <a:xfrm>
-            <a:off x="594360" y="2679191"/>
-            <a:ext cx="1389888" cy="201168"/>
-          </a:xfrm>
-          <a:prstGeom prst="rect">
-            <a:avLst/>
-          </a:prstGeom>
-          <a:noFill/>
-        </p:spPr>
-        <p:txBody>
-          <a:bodyPr wrap="none" lIns="0" rIns="0" tIns="0" bIns="0" anchor="ctr">
-            <a:spAutoFit/>
-          </a:bodyPr>
-          <a:lstStyle/>
-          <a:p>
-            <a:pPr algn="l">
-              <a:defRPr sz="1400" b="0">
-                <a:solidFill>
-                  <a:srgbClr val="53665D"/>
-                </a:solidFill>
-                <a:latin typeface="Arial"/>
-              </a:defRPr>
-            </a:pPr>
-            <a:r>
-              <a:t>depth = 3</a:t>
-            </a:r>
-          </a:p>
-        </p:txBody>
-      </p:sp>
-      <p:sp>
-        <p:nvSpPr>
-          <p:cNvPr id="26" name="TextBox 25"/>
-          <p:cNvSpPr txBox="1"/>
-          <p:nvPr/>
-        </p:nvSpPr>
-        <p:spPr>
-          <a:xfrm>
-            <a:off x="594360" y="3099816"/>
-            <a:ext cx="1389888" cy="283464"/>
-          </a:xfrm>
-          <a:prstGeom prst="rect">
-            <a:avLst/>
-          </a:prstGeom>
-          <a:noFill/>
-        </p:spPr>
-        <p:txBody>
-          <a:bodyPr wrap="none" lIns="0" rIns="0" tIns="0" bIns="0" anchor="ctr">
-            <a:spAutoFit/>
-          </a:bodyPr>
-          <a:lstStyle/>
-          <a:p>
-            <a:pPr algn="l">
-              <a:defRPr sz="2200" b="1">
-                <a:solidFill>
-                  <a:srgbClr val="245B43"/>
-                </a:solidFill>
-                <a:latin typeface="Arial"/>
-              </a:defRPr>
-            </a:pPr>
-            <a:r>
-              <a:t>2  HUMAN</a:t>
-            </a:r>
-          </a:p>
-        </p:txBody>
-      </p:sp>
-      <p:sp>
-        <p:nvSpPr>
-          <p:cNvPr id="27" name="TextBox 26"/>
-          <p:cNvSpPr txBox="1"/>
-          <p:nvPr/>
-        </p:nvSpPr>
-        <p:spPr>
-          <a:xfrm>
-            <a:off x="594360" y="3419856"/>
-            <a:ext cx="1389888" cy="228600"/>
-          </a:xfrm>
-          <a:prstGeom prst="rect">
-            <a:avLst/>
-          </a:prstGeom>
-          <a:noFill/>
-        </p:spPr>
-        <p:txBody>
-          <a:bodyPr wrap="none" lIns="0" rIns="0" tIns="0" bIns="0" anchor="ctr">
-            <a:spAutoFit/>
-          </a:bodyPr>
-          <a:lstStyle/>
-          <a:p>
-            <a:pPr algn="l">
-              <a:defRPr sz="1800" b="1">
-                <a:solidFill>
-                  <a:srgbClr val="245B43"/>
-                </a:solidFill>
-                <a:latin typeface="Arial"/>
-              </a:defRPr>
-            </a:pPr>
-            <a:r>
-              <a:t>MIN</a:t>
-            </a:r>
-          </a:p>
-        </p:txBody>
-      </p:sp>
-      <p:sp>
-        <p:nvSpPr>
-          <p:cNvPr id="28" name="TextBox 27"/>
-          <p:cNvSpPr txBox="1"/>
-          <p:nvPr/>
-        </p:nvSpPr>
-        <p:spPr>
-          <a:xfrm>
-            <a:off x="594360" y="3703320"/>
-            <a:ext cx="1389888" cy="201168"/>
-          </a:xfrm>
-          <a:prstGeom prst="rect">
-            <a:avLst/>
-          </a:prstGeom>
-          <a:noFill/>
-        </p:spPr>
-        <p:txBody>
-          <a:bodyPr wrap="none" lIns="0" rIns="0" tIns="0" bIns="0" anchor="ctr">
-            <a:spAutoFit/>
-          </a:bodyPr>
-          <a:lstStyle/>
-          <a:p>
-            <a:pPr algn="l">
-              <a:defRPr sz="1400" b="0">
-                <a:solidFill>
-                  <a:srgbClr val="53665D"/>
-                </a:solidFill>
-                <a:latin typeface="Arial"/>
-              </a:defRPr>
-            </a:pPr>
-            <a:r>
-              <a:t>minimax()</a:t>
-            </a:r>
-          </a:p>
-        </p:txBody>
-      </p:sp>
-      <p:sp>
-        <p:nvSpPr>
-          <p:cNvPr id="29" name="TextBox 28"/>
-          <p:cNvSpPr txBox="1"/>
-          <p:nvPr/>
-        </p:nvSpPr>
-        <p:spPr>
-          <a:xfrm>
-            <a:off x="594360" y="3941064"/>
-            <a:ext cx="1389888" cy="201168"/>
-          </a:xfrm>
-          <a:prstGeom prst="rect">
-            <a:avLst/>
-          </a:prstGeom>
-          <a:noFill/>
-        </p:spPr>
-        <p:txBody>
-          <a:bodyPr wrap="none" lIns="0" rIns="0" tIns="0" bIns="0" anchor="ctr">
-            <a:spAutoFit/>
-          </a:bodyPr>
-          <a:lstStyle/>
-          <a:p>
-            <a:pPr algn="l">
-              <a:defRPr sz="1400" b="0">
-                <a:solidFill>
-                  <a:srgbClr val="53665D"/>
-                </a:solidFill>
-                <a:latin typeface="Arial"/>
-              </a:defRPr>
-            </a:pPr>
-            <a:r>
-              <a:t>depth = 2</a:t>
-            </a:r>
-          </a:p>
-        </p:txBody>
-      </p:sp>
-      <p:sp>
-        <p:nvSpPr>
-          <p:cNvPr id="30" name="TextBox 29"/>
-          <p:cNvSpPr txBox="1"/>
-          <p:nvPr/>
-        </p:nvSpPr>
-        <p:spPr>
-          <a:xfrm>
-            <a:off x="594360" y="4443984"/>
-            <a:ext cx="1389888" cy="283464"/>
-          </a:xfrm>
-          <a:prstGeom prst="rect">
-            <a:avLst/>
-          </a:prstGeom>
-          <a:noFill/>
-        </p:spPr>
-        <p:txBody>
-          <a:bodyPr wrap="none" lIns="0" rIns="0" tIns="0" bIns="0" anchor="ctr">
-            <a:spAutoFit/>
-          </a:bodyPr>
-          <a:lstStyle/>
-          <a:p>
-            <a:pPr algn="l">
-              <a:defRPr sz="2200" b="1">
-                <a:solidFill>
-                  <a:srgbClr val="9D3E32"/>
-                </a:solidFill>
-                <a:latin typeface="Arial"/>
-              </a:defRPr>
-            </a:pPr>
-            <a:r>
-              <a:t>3  BOT</a:t>
-            </a:r>
-          </a:p>
-        </p:txBody>
-      </p:sp>
-      <p:sp>
-        <p:nvSpPr>
-          <p:cNvPr id="31" name="TextBox 30"/>
-          <p:cNvSpPr txBox="1"/>
-          <p:nvPr/>
-        </p:nvSpPr>
-        <p:spPr>
-          <a:xfrm>
-            <a:off x="594360" y="4764024"/>
-            <a:ext cx="1389888" cy="228600"/>
-          </a:xfrm>
-          <a:prstGeom prst="rect">
-            <a:avLst/>
-          </a:prstGeom>
-          <a:noFill/>
-        </p:spPr>
-        <p:txBody>
-          <a:bodyPr wrap="none" lIns="0" rIns="0" tIns="0" bIns="0" anchor="ctr">
-            <a:spAutoFit/>
-          </a:bodyPr>
-          <a:lstStyle/>
-          <a:p>
-            <a:pPr algn="l">
-              <a:defRPr sz="1800" b="1">
-                <a:solidFill>
-                  <a:srgbClr val="9D3E32"/>
-                </a:solidFill>
-                <a:latin typeface="Arial"/>
-              </a:defRPr>
-            </a:pPr>
-            <a:r>
-              <a:t>MAX</a:t>
-            </a:r>
-          </a:p>
-        </p:txBody>
-      </p:sp>
-      <p:sp>
-        <p:nvSpPr>
-          <p:cNvPr id="32" name="TextBox 31"/>
-          <p:cNvSpPr txBox="1"/>
-          <p:nvPr/>
-        </p:nvSpPr>
-        <p:spPr>
-          <a:xfrm>
-            <a:off x="594360" y="5047488"/>
-            <a:ext cx="1389888" cy="201168"/>
-          </a:xfrm>
-          <a:prstGeom prst="rect">
-            <a:avLst/>
-          </a:prstGeom>
-          <a:noFill/>
-        </p:spPr>
-        <p:txBody>
-          <a:bodyPr wrap="none" lIns="0" rIns="0" tIns="0" bIns="0" anchor="ctr">
-            <a:spAutoFit/>
-          </a:bodyPr>
-          <a:lstStyle/>
-          <a:p>
-            <a:pPr algn="l">
-              <a:defRPr sz="1400" b="0">
-                <a:solidFill>
-                  <a:srgbClr val="53665D"/>
-                </a:solidFill>
-                <a:latin typeface="Arial"/>
-              </a:defRPr>
-            </a:pPr>
-            <a:r>
-              <a:t>minimax()</a:t>
-            </a:r>
-          </a:p>
-        </p:txBody>
-      </p:sp>
-      <p:sp>
-        <p:nvSpPr>
-          <p:cNvPr id="33" name="TextBox 32"/>
-          <p:cNvSpPr txBox="1"/>
-          <p:nvPr/>
-        </p:nvSpPr>
-        <p:spPr>
-          <a:xfrm>
-            <a:off x="594360" y="5285232"/>
-            <a:ext cx="1389888" cy="201168"/>
-          </a:xfrm>
-          <a:prstGeom prst="rect">
-            <a:avLst/>
-          </a:prstGeom>
-          <a:noFill/>
-        </p:spPr>
-        <p:txBody>
-          <a:bodyPr wrap="none" lIns="0" rIns="0" tIns="0" bIns="0" anchor="ctr">
-            <a:spAutoFit/>
-          </a:bodyPr>
-          <a:lstStyle/>
-          <a:p>
-            <a:pPr algn="l">
-              <a:defRPr sz="1400" b="0">
-                <a:solidFill>
-                  <a:srgbClr val="53665D"/>
-                </a:solidFill>
-                <a:latin typeface="Arial"/>
-              </a:defRPr>
-            </a:pPr>
-            <a:r>
-              <a:t>depth = 1</a:t>
-            </a:r>
-          </a:p>
-        </p:txBody>
-      </p:sp>
-      <p:sp>
-        <p:nvSpPr>
-          <p:cNvPr id="34" name="TextBox 33"/>
-          <p:cNvSpPr txBox="1"/>
-          <p:nvPr/>
-        </p:nvSpPr>
-        <p:spPr>
-          <a:xfrm>
-            <a:off x="594360" y="5769864"/>
-            <a:ext cx="1389888" cy="283464"/>
-          </a:xfrm>
-          <a:prstGeom prst="rect">
-            <a:avLst/>
-          </a:prstGeom>
-          <a:noFill/>
-        </p:spPr>
-        <p:txBody>
-          <a:bodyPr wrap="none" lIns="0" rIns="0" tIns="0" bIns="0" anchor="ctr">
-            <a:spAutoFit/>
-          </a:bodyPr>
-          <a:lstStyle/>
-          <a:p>
-            <a:pPr algn="l">
-              <a:defRPr sz="2200" b="1">
-                <a:solidFill>
-                  <a:srgbClr val="17382D"/>
-                </a:solidFill>
-                <a:latin typeface="Arial"/>
-              </a:defRPr>
-            </a:pPr>
-            <a:r>
-              <a:t>SCORE</a:t>
-            </a:r>
-          </a:p>
-        </p:txBody>
-      </p:sp>
-      <p:sp>
-        <p:nvSpPr>
-          <p:cNvPr id="35" name="TextBox 34"/>
-          <p:cNvSpPr txBox="1"/>
-          <p:nvPr/>
-        </p:nvSpPr>
-        <p:spPr>
-          <a:xfrm>
-            <a:off x="594360" y="6089903"/>
-            <a:ext cx="1389888" cy="228600"/>
-          </a:xfrm>
-          <a:prstGeom prst="rect">
-            <a:avLst/>
-          </a:prstGeom>
-          <a:noFill/>
-        </p:spPr>
-        <p:txBody>
-          <a:bodyPr wrap="none" lIns="0" rIns="0" tIns="0" bIns="0" anchor="ctr">
-            <a:spAutoFit/>
-          </a:bodyPr>
-          <a:lstStyle/>
-          <a:p>
-            <a:pPr algn="l">
-              <a:defRPr sz="1800" b="1">
-                <a:solidFill>
-                  <a:srgbClr val="17382D"/>
-                </a:solidFill>
-                <a:latin typeface="Arial"/>
-              </a:defRPr>
-            </a:pPr>
-            <a:r>
-              <a:t>EVALUATE</a:t>
-            </a:r>
-          </a:p>
-        </p:txBody>
-      </p:sp>
-      <p:sp>
-        <p:nvSpPr>
-          <p:cNvPr id="36" name="TextBox 35"/>
-          <p:cNvSpPr txBox="1"/>
-          <p:nvPr/>
-        </p:nvSpPr>
-        <p:spPr>
-          <a:xfrm>
-            <a:off x="594360" y="6373368"/>
-            <a:ext cx="1389888" cy="201168"/>
-          </a:xfrm>
-          <a:prstGeom prst="rect">
-            <a:avLst/>
-          </a:prstGeom>
-          <a:noFill/>
-        </p:spPr>
-        <p:txBody>
-          <a:bodyPr wrap="none" lIns="0" rIns="0" tIns="0" bIns="0" anchor="ctr">
-            <a:spAutoFit/>
-          </a:bodyPr>
-          <a:lstStyle/>
-          <a:p>
-            <a:pPr algn="l">
-              <a:defRPr sz="1400" b="0">
-                <a:solidFill>
-                  <a:srgbClr val="53665D"/>
-                </a:solidFill>
-                <a:latin typeface="Arial"/>
-              </a:defRPr>
-            </a:pPr>
-            <a:r>
-              <a:t>evaluateBoard()</a:t>
-            </a:r>
-          </a:p>
-        </p:txBody>
-      </p:sp>
-      <p:sp>
-        <p:nvSpPr>
-          <p:cNvPr id="37" name="TextBox 36"/>
-          <p:cNvSpPr txBox="1"/>
-          <p:nvPr/>
-        </p:nvSpPr>
-        <p:spPr>
-          <a:xfrm>
-            <a:off x="594360" y="6611112"/>
-            <a:ext cx="1389888" cy="201168"/>
-          </a:xfrm>
-          <a:prstGeom prst="rect">
-            <a:avLst/>
-          </a:prstGeom>
-          <a:noFill/>
-        </p:spPr>
-        <p:txBody>
-          <a:bodyPr wrap="none" lIns="0" rIns="0" tIns="0" bIns="0" anchor="ctr">
-            <a:spAutoFit/>
-          </a:bodyPr>
-          <a:lstStyle/>
-          <a:p>
-            <a:pPr algn="l">
-              <a:defRPr sz="1400" b="0">
-                <a:solidFill>
-                  <a:srgbClr val="53665D"/>
-                </a:solidFill>
-                <a:latin typeface="Arial"/>
-              </a:defRPr>
-            </a:pPr>
-            <a:r>
-              <a:t>depth = 0</a:t>
-            </a:r>
-          </a:p>
-        </p:txBody>
-      </p:sp>
-      <p:sp>
-        <p:nvSpPr>
-          <p:cNvPr id="38" name="Rounded Rectangle 37"/>
+      <p:sp>
+        <p:nvSpPr>
+          <p:cNvPr id="17" name="Rounded Rectangle 16"/>
           <p:cNvSpPr/>
           <p:nvPr/>
         </p:nvSpPr>
         <p:spPr>
           <a:xfrm>
-            <a:off x="6217920" y="1810512"/>
-            <a:ext cx="3474720" cy="804672"/>
+            <a:off x="5349240" y="1353312"/>
+            <a:ext cx="3931920" cy="1051560"/>
           </a:xfrm>
           <a:prstGeom prst="roundRect">
             <a:avLst>
@@ -4931,14 +4176,14 @@
       </p:sp>
       <p:sp>
         <p:nvSpPr>
-          <p:cNvPr id="39" name="TextBox 38"/>
+          <p:cNvPr id="18" name="TextBox 17"/>
           <p:cNvSpPr txBox="1"/>
           <p:nvPr/>
         </p:nvSpPr>
         <p:spPr>
           <a:xfrm>
-            <a:off x="6309359" y="1883664"/>
-            <a:ext cx="3291839" cy="310896"/>
+            <a:off x="5458968" y="1490472"/>
+            <a:ext cx="3712463" cy="310896"/>
           </a:xfrm>
           <a:prstGeom prst="rect">
             <a:avLst/>
@@ -4960,21 +4205,21 @@
               </a:defRPr>
             </a:pPr>
             <a:r>
-              <a:t>BOT chooses A</a:t>
-            </a:r>
-          </a:p>
-        </p:txBody>
-      </p:sp>
-      <p:sp>
-        <p:nvSpPr>
-          <p:cNvPr id="40" name="TextBox 39"/>
+              <a:t>BOT · choose A</a:t>
+            </a:r>
+          </a:p>
+        </p:txBody>
+      </p:sp>
+      <p:sp>
+        <p:nvSpPr>
+          <p:cNvPr id="19" name="TextBox 18"/>
           <p:cNvSpPr txBox="1"/>
           <p:nvPr/>
         </p:nvSpPr>
         <p:spPr>
           <a:xfrm>
-            <a:off x="6309359" y="2267712"/>
-            <a:ext cx="3291839" cy="237744"/>
+            <a:off x="5458968" y="1947672"/>
+            <a:ext cx="3712463" cy="301752"/>
           </a:xfrm>
           <a:prstGeom prst="rect">
             <a:avLst/>
@@ -4988,7 +4233,7 @@
           <a:lstStyle/>
           <a:p>
             <a:pPr algn="ctr">
-              <a:defRPr sz="2000" b="1">
+              <a:defRPr sz="2700" b="1">
                 <a:solidFill>
                   <a:srgbClr val="17382D"/>
                 </a:solidFill>
@@ -5003,14 +4248,14 @@
       </p:sp>
       <p:sp>
         <p:nvSpPr>
-          <p:cNvPr id="41" name="Rounded Rectangle 40"/>
+          <p:cNvPr id="20" name="Rounded Rectangle 19"/>
           <p:cNvSpPr/>
           <p:nvPr/>
         </p:nvSpPr>
         <p:spPr>
           <a:xfrm>
-            <a:off x="3337560" y="3063240"/>
-            <a:ext cx="3017520" cy="804672"/>
+            <a:off x="1783079" y="3182112"/>
+            <a:ext cx="3931920" cy="1051560"/>
           </a:xfrm>
           <a:prstGeom prst="roundRect">
             <a:avLst>
@@ -5050,14 +4295,14 @@
       </p:sp>
       <p:sp>
         <p:nvSpPr>
-          <p:cNvPr id="42" name="TextBox 41"/>
+          <p:cNvPr id="21" name="TextBox 20"/>
           <p:cNvSpPr txBox="1"/>
           <p:nvPr/>
         </p:nvSpPr>
         <p:spPr>
           <a:xfrm>
-            <a:off x="3429000" y="3127248"/>
-            <a:ext cx="2834640" cy="246888"/>
+            <a:off x="1892807" y="3319272"/>
+            <a:ext cx="3712463" cy="292608"/>
           </a:xfrm>
           <a:prstGeom prst="rect">
             <a:avLst/>
@@ -5071,7 +4316,7 @@
           <a:lstStyle/>
           <a:p>
             <a:pPr algn="ctr">
-              <a:defRPr sz="1800" b="1">
+              <a:defRPr sz="2400" b="1">
                 <a:solidFill>
                   <a:srgbClr val="245B43"/>
                 </a:solidFill>
@@ -5079,21 +4324,21 @@
               </a:defRPr>
             </a:pPr>
             <a:r>
-              <a:t>After move A</a:t>
-            </a:r>
-          </a:p>
-        </p:txBody>
-      </p:sp>
-      <p:sp>
-        <p:nvSpPr>
-          <p:cNvPr id="43" name="TextBox 42"/>
+              <a:t>HUMAN · after A</a:t>
+            </a:r>
+          </a:p>
+        </p:txBody>
+      </p:sp>
+      <p:sp>
+        <p:nvSpPr>
+          <p:cNvPr id="22" name="TextBox 21"/>
           <p:cNvSpPr txBox="1"/>
           <p:nvPr/>
         </p:nvSpPr>
         <p:spPr>
           <a:xfrm>
-            <a:off x="3429000" y="3465576"/>
-            <a:ext cx="2834640" cy="274320"/>
+            <a:off x="1892807" y="3776472"/>
+            <a:ext cx="3712463" cy="301752"/>
           </a:xfrm>
           <a:prstGeom prst="rect">
             <a:avLst/>
@@ -5107,7 +4352,7 @@
           <a:lstStyle/>
           <a:p>
             <a:pPr algn="ctr">
-              <a:defRPr sz="2400" b="1">
+              <a:defRPr sz="2700" b="1">
                 <a:solidFill>
                   <a:srgbClr val="245B43"/>
                 </a:solidFill>
@@ -5122,97 +4367,14 @@
       </p:sp>
       <p:sp>
         <p:nvSpPr>
-          <p:cNvPr id="44" name="Rounded Rectangle 43"/>
+          <p:cNvPr id="23" name="Rounded Rectangle 22"/>
           <p:cNvSpPr/>
           <p:nvPr/>
         </p:nvSpPr>
         <p:spPr>
           <a:xfrm>
-            <a:off x="5879592" y="2724912"/>
-            <a:ext cx="384048" cy="256032"/>
-          </a:xfrm>
-          <a:prstGeom prst="roundRect">
-            <a:avLst>
-              <a:gd name="adj" fmla="val 8000"/>
-            </a:avLst>
-          </a:prstGeom>
-          <a:solidFill>
-            <a:srgbClr val="F7F8F4"/>
-          </a:solidFill>
-          <a:ln w="12700">
-            <a:solidFill>
-              <a:srgbClr val="F7F8F4"/>
-            </a:solidFill>
-          </a:ln>
-        </p:spPr>
-        <p:style>
-          <a:lnRef idx="1">
-            <a:schemeClr val="accent1"/>
-          </a:lnRef>
-          <a:fillRef idx="3">
-            <a:schemeClr val="accent1"/>
-          </a:fillRef>
-          <a:effectRef idx="2">
-            <a:schemeClr val="accent1"/>
-          </a:effectRef>
-          <a:fontRef idx="minor">
-            <a:schemeClr val="lt1"/>
-          </a:fontRef>
-        </p:style>
-        <p:txBody>
-          <a:bodyPr rtlCol="0" anchor="ctr"/>
-          <a:lstStyle/>
-          <a:p>
-            <a:pPr algn="ctr"/>
-          </a:p>
-        </p:txBody>
-      </p:sp>
-      <p:sp>
-        <p:nvSpPr>
-          <p:cNvPr id="45" name="TextBox 44"/>
-          <p:cNvSpPr txBox="1"/>
-          <p:nvPr/>
-        </p:nvSpPr>
-        <p:spPr>
-          <a:xfrm>
-            <a:off x="5879592" y="2724912"/>
-            <a:ext cx="384048" cy="256032"/>
-          </a:xfrm>
-          <a:prstGeom prst="rect">
-            <a:avLst/>
-          </a:prstGeom>
-          <a:noFill/>
-        </p:spPr>
-        <p:txBody>
-          <a:bodyPr wrap="none" lIns="0" rIns="0" tIns="0" bIns="0" anchor="ctr">
-            <a:spAutoFit/>
-          </a:bodyPr>
-          <a:lstStyle/>
-          <a:p>
-            <a:pPr algn="ctr">
-              <a:defRPr sz="1800" b="1">
-                <a:solidFill>
-                  <a:srgbClr val="17382D"/>
-                </a:solidFill>
-                <a:latin typeface="Arial"/>
-              </a:defRPr>
-            </a:pPr>
-            <a:r>
-              <a:t>A</a:t>
-            </a:r>
-          </a:p>
-        </p:txBody>
-      </p:sp>
-      <p:sp>
-        <p:nvSpPr>
-          <p:cNvPr id="46" name="Rounded Rectangle 45"/>
-          <p:cNvSpPr/>
-          <p:nvPr/>
-        </p:nvSpPr>
-        <p:spPr>
-          <a:xfrm>
-            <a:off x="2103120" y="4407408"/>
-            <a:ext cx="2377440" cy="804672"/>
+            <a:off x="457200" y="5102352"/>
+            <a:ext cx="3017520" cy="1051560"/>
           </a:xfrm>
           <a:prstGeom prst="roundRect">
             <a:avLst>
@@ -5252,14 +4414,14 @@
       </p:sp>
       <p:sp>
         <p:nvSpPr>
-          <p:cNvPr id="47" name="TextBox 46"/>
+          <p:cNvPr id="24" name="TextBox 23"/>
           <p:cNvSpPr txBox="1"/>
           <p:nvPr/>
         </p:nvSpPr>
         <p:spPr>
           <a:xfrm>
-            <a:off x="2148839" y="4471416"/>
-            <a:ext cx="2286000" cy="237744"/>
+            <a:off x="548640" y="5239512"/>
+            <a:ext cx="2834640" cy="292608"/>
           </a:xfrm>
           <a:prstGeom prst="rect">
             <a:avLst/>
@@ -5273,7 +4435,7 @@
           <a:lstStyle/>
           <a:p>
             <a:pPr algn="ctr">
-              <a:defRPr sz="1700" b="1">
+              <a:defRPr sz="2100" b="1">
                 <a:solidFill>
                   <a:srgbClr val="9D3E32"/>
                 </a:solidFill>
@@ -5281,21 +4443,21 @@
               </a:defRPr>
             </a:pPr>
             <a:r>
-              <a:t>After human H1</a:t>
-            </a:r>
-          </a:p>
-        </p:txBody>
-      </p:sp>
-      <p:sp>
-        <p:nvSpPr>
-          <p:cNvPr id="48" name="TextBox 47"/>
+              <a:t>BOT · after H1</a:t>
+            </a:r>
+          </a:p>
+        </p:txBody>
+      </p:sp>
+      <p:sp>
+        <p:nvSpPr>
+          <p:cNvPr id="25" name="TextBox 24"/>
           <p:cNvSpPr txBox="1"/>
           <p:nvPr/>
         </p:nvSpPr>
         <p:spPr>
           <a:xfrm>
-            <a:off x="2148839" y="4800600"/>
-            <a:ext cx="2286000" cy="274320"/>
+            <a:off x="548640" y="5696712"/>
+            <a:ext cx="2834640" cy="292608"/>
           </a:xfrm>
           <a:prstGeom prst="rect">
             <a:avLst/>
@@ -5309,7 +4471,7 @@
           <a:lstStyle/>
           <a:p>
             <a:pPr algn="ctr">
-              <a:defRPr sz="2000" b="1">
+              <a:defRPr sz="2400" b="1">
                 <a:solidFill>
                   <a:srgbClr val="9D3E32"/>
                 </a:solidFill>
@@ -5324,14 +4486,14 @@
       </p:sp>
       <p:sp>
         <p:nvSpPr>
-          <p:cNvPr id="49" name="Rounded Rectangle 48"/>
+          <p:cNvPr id="26" name="Rounded Rectangle 25"/>
           <p:cNvSpPr/>
           <p:nvPr/>
         </p:nvSpPr>
         <p:spPr>
           <a:xfrm>
-            <a:off x="2194560" y="5742432"/>
-            <a:ext cx="1005840" cy="749808"/>
+            <a:off x="594359" y="7022592"/>
+            <a:ext cx="1188720" cy="822960"/>
           </a:xfrm>
           <a:prstGeom prst="roundRect">
             <a:avLst>
@@ -5371,14 +4533,14 @@
       </p:sp>
       <p:sp>
         <p:nvSpPr>
-          <p:cNvPr id="50" name="TextBox 49"/>
+          <p:cNvPr id="27" name="TextBox 26"/>
           <p:cNvSpPr txBox="1"/>
           <p:nvPr/>
         </p:nvSpPr>
         <p:spPr>
           <a:xfrm>
-            <a:off x="2240280" y="5797296"/>
-            <a:ext cx="914400" cy="182880"/>
+            <a:off x="640079" y="7095744"/>
+            <a:ext cx="1097280" cy="201168"/>
           </a:xfrm>
           <a:prstGeom prst="rect">
             <a:avLst/>
@@ -5392,7 +4554,7 @@
           <a:lstStyle/>
           <a:p>
             <a:pPr algn="ctr">
-              <a:defRPr sz="1400" b="0">
+              <a:defRPr sz="1500" b="0">
                 <a:solidFill>
                   <a:srgbClr val="53665D"/>
                 </a:solidFill>
@@ -5407,14 +4569,14 @@
       </p:sp>
       <p:sp>
         <p:nvSpPr>
-          <p:cNvPr id="51" name="TextBox 50"/>
+          <p:cNvPr id="28" name="TextBox 27"/>
           <p:cNvSpPr txBox="1"/>
           <p:nvPr/>
         </p:nvSpPr>
         <p:spPr>
           <a:xfrm>
-            <a:off x="2240280" y="6035040"/>
-            <a:ext cx="914400" cy="365760"/>
+            <a:off x="640079" y="7379208"/>
+            <a:ext cx="1097280" cy="365760"/>
           </a:xfrm>
           <a:prstGeom prst="rect">
             <a:avLst/>
@@ -5428,7 +4590,7 @@
           <a:lstStyle/>
           <a:p>
             <a:pPr algn="ctr">
-              <a:defRPr sz="2900" b="1">
+              <a:defRPr sz="3200" b="1">
                 <a:solidFill>
                   <a:srgbClr val="17382D"/>
                 </a:solidFill>
@@ -5443,14 +4605,14 @@
       </p:sp>
       <p:sp>
         <p:nvSpPr>
-          <p:cNvPr id="52" name="Rounded Rectangle 51"/>
+          <p:cNvPr id="29" name="Rounded Rectangle 28"/>
           <p:cNvSpPr/>
           <p:nvPr/>
         </p:nvSpPr>
         <p:spPr>
           <a:xfrm>
-            <a:off x="3383280" y="5742432"/>
-            <a:ext cx="1005840" cy="749808"/>
+            <a:off x="2148840" y="7022592"/>
+            <a:ext cx="1188720" cy="822960"/>
           </a:xfrm>
           <a:prstGeom prst="roundRect">
             <a:avLst>
@@ -5490,14 +4652,14 @@
       </p:sp>
       <p:sp>
         <p:nvSpPr>
-          <p:cNvPr id="53" name="TextBox 52"/>
+          <p:cNvPr id="30" name="TextBox 29"/>
           <p:cNvSpPr txBox="1"/>
           <p:nvPr/>
         </p:nvSpPr>
         <p:spPr>
           <a:xfrm>
-            <a:off x="3429000" y="5797296"/>
-            <a:ext cx="914400" cy="182880"/>
+            <a:off x="2194560" y="7095744"/>
+            <a:ext cx="1097280" cy="201168"/>
           </a:xfrm>
           <a:prstGeom prst="rect">
             <a:avLst/>
@@ -5511,7 +4673,7 @@
           <a:lstStyle/>
           <a:p>
             <a:pPr algn="ctr">
-              <a:defRPr sz="1400" b="0">
+              <a:defRPr sz="1500" b="0">
                 <a:solidFill>
                   <a:srgbClr val="53665D"/>
                 </a:solidFill>
@@ -5526,14 +4688,14 @@
       </p:sp>
       <p:sp>
         <p:nvSpPr>
-          <p:cNvPr id="54" name="TextBox 53"/>
+          <p:cNvPr id="31" name="TextBox 30"/>
           <p:cNvSpPr txBox="1"/>
           <p:nvPr/>
         </p:nvSpPr>
         <p:spPr>
           <a:xfrm>
-            <a:off x="3429000" y="6035040"/>
-            <a:ext cx="914400" cy="365760"/>
+            <a:off x="2194560" y="7379208"/>
+            <a:ext cx="1097280" cy="365760"/>
           </a:xfrm>
           <a:prstGeom prst="rect">
             <a:avLst/>
@@ -5547,7 +4709,7 @@
           <a:lstStyle/>
           <a:p>
             <a:pPr algn="ctr">
-              <a:defRPr sz="2900" b="1">
+              <a:defRPr sz="3200" b="1">
                 <a:solidFill>
                   <a:srgbClr val="17382D"/>
                 </a:solidFill>
@@ -5562,14 +4724,14 @@
       </p:sp>
       <p:sp>
         <p:nvSpPr>
-          <p:cNvPr id="55" name="Rounded Rectangle 54"/>
+          <p:cNvPr id="32" name="Rounded Rectangle 31"/>
           <p:cNvSpPr/>
           <p:nvPr/>
         </p:nvSpPr>
         <p:spPr>
           <a:xfrm>
-            <a:off x="5212080" y="4407408"/>
-            <a:ext cx="2377440" cy="804672"/>
+            <a:off x="4023360" y="5102352"/>
+            <a:ext cx="3017520" cy="1051560"/>
           </a:xfrm>
           <a:prstGeom prst="roundRect">
             <a:avLst>
@@ -5609,14 +4771,14 @@
       </p:sp>
       <p:sp>
         <p:nvSpPr>
-          <p:cNvPr id="56" name="TextBox 55"/>
+          <p:cNvPr id="33" name="TextBox 32"/>
           <p:cNvSpPr txBox="1"/>
           <p:nvPr/>
         </p:nvSpPr>
         <p:spPr>
           <a:xfrm>
-            <a:off x="5257800" y="4471416"/>
-            <a:ext cx="2286000" cy="237744"/>
+            <a:off x="4114800" y="5239512"/>
+            <a:ext cx="2834640" cy="292608"/>
           </a:xfrm>
           <a:prstGeom prst="rect">
             <a:avLst/>
@@ -5630,7 +4792,7 @@
           <a:lstStyle/>
           <a:p>
             <a:pPr algn="ctr">
-              <a:defRPr sz="1700" b="1">
+              <a:defRPr sz="2100" b="1">
                 <a:solidFill>
                   <a:srgbClr val="9D3E32"/>
                 </a:solidFill>
@@ -5638,21 +4800,21 @@
               </a:defRPr>
             </a:pPr>
             <a:r>
-              <a:t>After human H2</a:t>
-            </a:r>
-          </a:p>
-        </p:txBody>
-      </p:sp>
-      <p:sp>
-        <p:nvSpPr>
-          <p:cNvPr id="57" name="TextBox 56"/>
+              <a:t>BOT · after H2</a:t>
+            </a:r>
+          </a:p>
+        </p:txBody>
+      </p:sp>
+      <p:sp>
+        <p:nvSpPr>
+          <p:cNvPr id="34" name="TextBox 33"/>
           <p:cNvSpPr txBox="1"/>
           <p:nvPr/>
         </p:nvSpPr>
         <p:spPr>
           <a:xfrm>
-            <a:off x="5257800" y="4800600"/>
-            <a:ext cx="2286000" cy="274320"/>
+            <a:off x="4114800" y="5696712"/>
+            <a:ext cx="2834640" cy="292608"/>
           </a:xfrm>
           <a:prstGeom prst="rect">
             <a:avLst/>
@@ -5666,7 +4828,7 @@
           <a:lstStyle/>
           <a:p>
             <a:pPr algn="ctr">
-              <a:defRPr sz="2000" b="1">
+              <a:defRPr sz="2400" b="1">
                 <a:solidFill>
                   <a:srgbClr val="9D3E32"/>
                 </a:solidFill>
@@ -5681,14 +4843,14 @@
       </p:sp>
       <p:sp>
         <p:nvSpPr>
-          <p:cNvPr id="58" name="Rounded Rectangle 57"/>
+          <p:cNvPr id="35" name="Rounded Rectangle 34"/>
           <p:cNvSpPr/>
           <p:nvPr/>
         </p:nvSpPr>
         <p:spPr>
           <a:xfrm>
-            <a:off x="5303520" y="5742432"/>
-            <a:ext cx="1005840" cy="749808"/>
+            <a:off x="4160520" y="7022592"/>
+            <a:ext cx="1188720" cy="822960"/>
           </a:xfrm>
           <a:prstGeom prst="roundRect">
             <a:avLst>
@@ -5728,14 +4890,14 @@
       </p:sp>
       <p:sp>
         <p:nvSpPr>
-          <p:cNvPr id="59" name="TextBox 58"/>
+          <p:cNvPr id="36" name="TextBox 35"/>
           <p:cNvSpPr txBox="1"/>
           <p:nvPr/>
         </p:nvSpPr>
         <p:spPr>
           <a:xfrm>
-            <a:off x="5349240" y="5797296"/>
-            <a:ext cx="914400" cy="182880"/>
+            <a:off x="4206240" y="7095744"/>
+            <a:ext cx="1097280" cy="201168"/>
           </a:xfrm>
           <a:prstGeom prst="rect">
             <a:avLst/>
@@ -5749,7 +4911,7 @@
           <a:lstStyle/>
           <a:p>
             <a:pPr algn="ctr">
-              <a:defRPr sz="1400" b="0">
+              <a:defRPr sz="1500" b="0">
                 <a:solidFill>
                   <a:srgbClr val="53665D"/>
                 </a:solidFill>
@@ -5764,14 +4926,14 @@
       </p:sp>
       <p:sp>
         <p:nvSpPr>
-          <p:cNvPr id="60" name="TextBox 59"/>
+          <p:cNvPr id="37" name="TextBox 36"/>
           <p:cNvSpPr txBox="1"/>
           <p:nvPr/>
         </p:nvSpPr>
         <p:spPr>
           <a:xfrm>
-            <a:off x="5349240" y="6035040"/>
-            <a:ext cx="914400" cy="365760"/>
+            <a:off x="4206240" y="7379208"/>
+            <a:ext cx="1097280" cy="365760"/>
           </a:xfrm>
           <a:prstGeom prst="rect">
             <a:avLst/>
@@ -5785,7 +4947,7 @@
           <a:lstStyle/>
           <a:p>
             <a:pPr algn="ctr">
-              <a:defRPr sz="2900" b="1">
+              <a:defRPr sz="3200" b="1">
                 <a:solidFill>
                   <a:srgbClr val="17382D"/>
                 </a:solidFill>
@@ -5800,14 +4962,14 @@
       </p:sp>
       <p:sp>
         <p:nvSpPr>
-          <p:cNvPr id="61" name="Rounded Rectangle 60"/>
+          <p:cNvPr id="38" name="Rounded Rectangle 37"/>
           <p:cNvSpPr/>
           <p:nvPr/>
         </p:nvSpPr>
         <p:spPr>
           <a:xfrm>
-            <a:off x="6492240" y="5742432"/>
-            <a:ext cx="1005840" cy="749808"/>
+            <a:off x="5714999" y="7022592"/>
+            <a:ext cx="1188720" cy="822960"/>
           </a:xfrm>
           <a:prstGeom prst="roundRect">
             <a:avLst>
@@ -5847,14 +5009,14 @@
       </p:sp>
       <p:sp>
         <p:nvSpPr>
-          <p:cNvPr id="62" name="TextBox 61"/>
+          <p:cNvPr id="39" name="TextBox 38"/>
           <p:cNvSpPr txBox="1"/>
           <p:nvPr/>
         </p:nvSpPr>
         <p:spPr>
           <a:xfrm>
-            <a:off x="6537960" y="5797296"/>
-            <a:ext cx="914400" cy="182880"/>
+            <a:off x="5760719" y="7095744"/>
+            <a:ext cx="1097280" cy="201168"/>
           </a:xfrm>
           <a:prstGeom prst="rect">
             <a:avLst/>
@@ -5868,7 +5030,7 @@
           <a:lstStyle/>
           <a:p>
             <a:pPr algn="ctr">
-              <a:defRPr sz="1400" b="0">
+              <a:defRPr sz="1500" b="0">
                 <a:solidFill>
                   <a:srgbClr val="53665D"/>
                 </a:solidFill>
@@ -5883,14 +5045,14 @@
       </p:sp>
       <p:sp>
         <p:nvSpPr>
-          <p:cNvPr id="63" name="TextBox 62"/>
+          <p:cNvPr id="40" name="TextBox 39"/>
           <p:cNvSpPr txBox="1"/>
           <p:nvPr/>
         </p:nvSpPr>
         <p:spPr>
           <a:xfrm>
-            <a:off x="6537960" y="6035040"/>
-            <a:ext cx="914400" cy="365760"/>
+            <a:off x="5760719" y="7379208"/>
+            <a:ext cx="1097280" cy="365760"/>
           </a:xfrm>
           <a:prstGeom prst="rect">
             <a:avLst/>
@@ -5904,7 +5066,7 @@
           <a:lstStyle/>
           <a:p>
             <a:pPr algn="ctr">
-              <a:defRPr sz="2900" b="1">
+              <a:defRPr sz="3200" b="1">
                 <a:solidFill>
                   <a:srgbClr val="936600"/>
                 </a:solidFill>
@@ -5919,14 +5081,14 @@
       </p:sp>
       <p:sp>
         <p:nvSpPr>
-          <p:cNvPr id="64" name="Rounded Rectangle 63"/>
+          <p:cNvPr id="41" name="Rounded Rectangle 40"/>
           <p:cNvSpPr/>
           <p:nvPr/>
         </p:nvSpPr>
         <p:spPr>
           <a:xfrm>
-            <a:off x="9555480" y="3063240"/>
-            <a:ext cx="3017520" cy="804672"/>
+            <a:off x="8915400" y="3182112"/>
+            <a:ext cx="3931920" cy="1051560"/>
           </a:xfrm>
           <a:prstGeom prst="roundRect">
             <a:avLst>
@@ -5966,14 +5128,14 @@
       </p:sp>
       <p:sp>
         <p:nvSpPr>
-          <p:cNvPr id="65" name="TextBox 64"/>
+          <p:cNvPr id="42" name="TextBox 41"/>
           <p:cNvSpPr txBox="1"/>
           <p:nvPr/>
         </p:nvSpPr>
         <p:spPr>
           <a:xfrm>
-            <a:off x="9646919" y="3127248"/>
-            <a:ext cx="2834640" cy="246888"/>
+            <a:off x="9025128" y="3319272"/>
+            <a:ext cx="3712463" cy="292608"/>
           </a:xfrm>
           <a:prstGeom prst="rect">
             <a:avLst/>
@@ -5987,7 +5149,7 @@
           <a:lstStyle/>
           <a:p>
             <a:pPr algn="ctr">
-              <a:defRPr sz="1800" b="1">
+              <a:defRPr sz="2400" b="1">
                 <a:solidFill>
                   <a:srgbClr val="245B43"/>
                 </a:solidFill>
@@ -5995,21 +5157,21 @@
               </a:defRPr>
             </a:pPr>
             <a:r>
-              <a:t>After move B</a:t>
-            </a:r>
-          </a:p>
-        </p:txBody>
-      </p:sp>
-      <p:sp>
-        <p:nvSpPr>
-          <p:cNvPr id="66" name="TextBox 65"/>
+              <a:t>HUMAN · after B</a:t>
+            </a:r>
+          </a:p>
+        </p:txBody>
+      </p:sp>
+      <p:sp>
+        <p:nvSpPr>
+          <p:cNvPr id="43" name="TextBox 42"/>
           <p:cNvSpPr txBox="1"/>
           <p:nvPr/>
         </p:nvSpPr>
         <p:spPr>
           <a:xfrm>
-            <a:off x="9646919" y="3465576"/>
-            <a:ext cx="2834640" cy="274320"/>
+            <a:off x="9025128" y="3776472"/>
+            <a:ext cx="3712463" cy="301752"/>
           </a:xfrm>
           <a:prstGeom prst="rect">
             <a:avLst/>
@@ -6023,7 +5185,7 @@
           <a:lstStyle/>
           <a:p>
             <a:pPr algn="ctr">
-              <a:defRPr sz="2400" b="1">
+              <a:defRPr sz="2700" b="1">
                 <a:solidFill>
                   <a:srgbClr val="245B43"/>
                 </a:solidFill>
@@ -6038,97 +5200,14 @@
       </p:sp>
       <p:sp>
         <p:nvSpPr>
-          <p:cNvPr id="67" name="Rounded Rectangle 66"/>
+          <p:cNvPr id="44" name="Rounded Rectangle 43"/>
           <p:cNvSpPr/>
           <p:nvPr/>
         </p:nvSpPr>
         <p:spPr>
           <a:xfrm>
-            <a:off x="9610344" y="2724912"/>
-            <a:ext cx="384048" cy="256032"/>
-          </a:xfrm>
-          <a:prstGeom prst="roundRect">
-            <a:avLst>
-              <a:gd name="adj" fmla="val 8000"/>
-            </a:avLst>
-          </a:prstGeom>
-          <a:solidFill>
-            <a:srgbClr val="F7F8F4"/>
-          </a:solidFill>
-          <a:ln w="12700">
-            <a:solidFill>
-              <a:srgbClr val="F7F8F4"/>
-            </a:solidFill>
-          </a:ln>
-        </p:spPr>
-        <p:style>
-          <a:lnRef idx="1">
-            <a:schemeClr val="accent1"/>
-          </a:lnRef>
-          <a:fillRef idx="3">
-            <a:schemeClr val="accent1"/>
-          </a:fillRef>
-          <a:effectRef idx="2">
-            <a:schemeClr val="accent1"/>
-          </a:effectRef>
-          <a:fontRef idx="minor">
-            <a:schemeClr val="lt1"/>
-          </a:fontRef>
-        </p:style>
-        <p:txBody>
-          <a:bodyPr rtlCol="0" anchor="ctr"/>
-          <a:lstStyle/>
-          <a:p>
-            <a:pPr algn="ctr"/>
-          </a:p>
-        </p:txBody>
-      </p:sp>
-      <p:sp>
-        <p:nvSpPr>
-          <p:cNvPr id="68" name="TextBox 67"/>
-          <p:cNvSpPr txBox="1"/>
-          <p:nvPr/>
-        </p:nvSpPr>
-        <p:spPr>
-          <a:xfrm>
-            <a:off x="9610344" y="2724912"/>
-            <a:ext cx="384048" cy="256032"/>
-          </a:xfrm>
-          <a:prstGeom prst="rect">
-            <a:avLst/>
-          </a:prstGeom>
-          <a:noFill/>
-        </p:spPr>
-        <p:txBody>
-          <a:bodyPr wrap="none" lIns="0" rIns="0" tIns="0" bIns="0" anchor="ctr">
-            <a:spAutoFit/>
-          </a:bodyPr>
-          <a:lstStyle/>
-          <a:p>
-            <a:pPr algn="ctr">
-              <a:defRPr sz="1800" b="1">
-                <a:solidFill>
-                  <a:srgbClr val="17382D"/>
-                </a:solidFill>
-                <a:latin typeface="Arial"/>
-              </a:defRPr>
-            </a:pPr>
-            <a:r>
-              <a:t>B</a:t>
-            </a:r>
-          </a:p>
-        </p:txBody>
-      </p:sp>
-      <p:sp>
-        <p:nvSpPr>
-          <p:cNvPr id="69" name="Rounded Rectangle 68"/>
-          <p:cNvSpPr/>
-          <p:nvPr/>
-        </p:nvSpPr>
-        <p:spPr>
-          <a:xfrm>
-            <a:off x="8321040" y="4407408"/>
-            <a:ext cx="2377440" cy="804672"/>
+            <a:off x="7589519" y="5102352"/>
+            <a:ext cx="3017520" cy="1051560"/>
           </a:xfrm>
           <a:prstGeom prst="roundRect">
             <a:avLst>
@@ -6168,14 +5247,14 @@
       </p:sp>
       <p:sp>
         <p:nvSpPr>
-          <p:cNvPr id="70" name="TextBox 69"/>
+          <p:cNvPr id="45" name="TextBox 44"/>
           <p:cNvSpPr txBox="1"/>
           <p:nvPr/>
         </p:nvSpPr>
         <p:spPr>
           <a:xfrm>
-            <a:off x="8366760" y="4471416"/>
-            <a:ext cx="2286000" cy="237744"/>
+            <a:off x="7680959" y="5239512"/>
+            <a:ext cx="2834640" cy="292608"/>
           </a:xfrm>
           <a:prstGeom prst="rect">
             <a:avLst/>
@@ -6189,7 +5268,7 @@
           <a:lstStyle/>
           <a:p>
             <a:pPr algn="ctr">
-              <a:defRPr sz="1700" b="1">
+              <a:defRPr sz="2100" b="1">
                 <a:solidFill>
                   <a:srgbClr val="9D3E32"/>
                 </a:solidFill>
@@ -6197,21 +5276,21 @@
               </a:defRPr>
             </a:pPr>
             <a:r>
-              <a:t>After human H1</a:t>
-            </a:r>
-          </a:p>
-        </p:txBody>
-      </p:sp>
-      <p:sp>
-        <p:nvSpPr>
-          <p:cNvPr id="71" name="TextBox 70"/>
+              <a:t>BOT · after H1</a:t>
+            </a:r>
+          </a:p>
+        </p:txBody>
+      </p:sp>
+      <p:sp>
+        <p:nvSpPr>
+          <p:cNvPr id="46" name="TextBox 45"/>
           <p:cNvSpPr txBox="1"/>
           <p:nvPr/>
         </p:nvSpPr>
         <p:spPr>
           <a:xfrm>
-            <a:off x="8366760" y="4800600"/>
-            <a:ext cx="2286000" cy="274320"/>
+            <a:off x="7680959" y="5696712"/>
+            <a:ext cx="2834640" cy="292608"/>
           </a:xfrm>
           <a:prstGeom prst="rect">
             <a:avLst/>
@@ -6225,7 +5304,7 @@
           <a:lstStyle/>
           <a:p>
             <a:pPr algn="ctr">
-              <a:defRPr sz="2000" b="1">
+              <a:defRPr sz="2400" b="1">
                 <a:solidFill>
                   <a:srgbClr val="9D3E32"/>
                 </a:solidFill>
@@ -6240,14 +5319,14 @@
       </p:sp>
       <p:sp>
         <p:nvSpPr>
-          <p:cNvPr id="72" name="Rounded Rectangle 71"/>
+          <p:cNvPr id="47" name="Rounded Rectangle 46"/>
           <p:cNvSpPr/>
           <p:nvPr/>
         </p:nvSpPr>
         <p:spPr>
           <a:xfrm>
-            <a:off x="8412480" y="5742432"/>
-            <a:ext cx="1005840" cy="749808"/>
+            <a:off x="7726679" y="7022592"/>
+            <a:ext cx="1188720" cy="822960"/>
           </a:xfrm>
           <a:prstGeom prst="roundRect">
             <a:avLst>
@@ -6287,14 +5366,14 @@
       </p:sp>
       <p:sp>
         <p:nvSpPr>
-          <p:cNvPr id="73" name="TextBox 72"/>
+          <p:cNvPr id="48" name="TextBox 47"/>
           <p:cNvSpPr txBox="1"/>
           <p:nvPr/>
         </p:nvSpPr>
         <p:spPr>
           <a:xfrm>
-            <a:off x="8458200" y="5797296"/>
-            <a:ext cx="914400" cy="182880"/>
+            <a:off x="7772400" y="7095744"/>
+            <a:ext cx="1097280" cy="201168"/>
           </a:xfrm>
           <a:prstGeom prst="rect">
             <a:avLst/>
@@ -6308,7 +5387,7 @@
           <a:lstStyle/>
           <a:p>
             <a:pPr algn="ctr">
-              <a:defRPr sz="1400" b="0">
+              <a:defRPr sz="1500" b="0">
                 <a:solidFill>
                   <a:srgbClr val="53665D"/>
                 </a:solidFill>
@@ -6323,14 +5402,14 @@
       </p:sp>
       <p:sp>
         <p:nvSpPr>
-          <p:cNvPr id="74" name="TextBox 73"/>
+          <p:cNvPr id="49" name="TextBox 48"/>
           <p:cNvSpPr txBox="1"/>
           <p:nvPr/>
         </p:nvSpPr>
         <p:spPr>
           <a:xfrm>
-            <a:off x="8458200" y="6035040"/>
-            <a:ext cx="914400" cy="365760"/>
+            <a:off x="7772400" y="7379208"/>
+            <a:ext cx="1097280" cy="365760"/>
           </a:xfrm>
           <a:prstGeom prst="rect">
             <a:avLst/>
@@ -6344,7 +5423,7 @@
           <a:lstStyle/>
           <a:p>
             <a:pPr algn="ctr">
-              <a:defRPr sz="2900" b="1">
+              <a:defRPr sz="3200" b="1">
                 <a:solidFill>
                   <a:srgbClr val="17382D"/>
                 </a:solidFill>
@@ -6359,14 +5438,14 @@
       </p:sp>
       <p:sp>
         <p:nvSpPr>
-          <p:cNvPr id="75" name="Rounded Rectangle 74"/>
+          <p:cNvPr id="50" name="Rounded Rectangle 49"/>
           <p:cNvSpPr/>
           <p:nvPr/>
         </p:nvSpPr>
         <p:spPr>
           <a:xfrm>
-            <a:off x="9601200" y="5742432"/>
-            <a:ext cx="1005840" cy="749808"/>
+            <a:off x="9281159" y="7022592"/>
+            <a:ext cx="1188720" cy="822960"/>
           </a:xfrm>
           <a:prstGeom prst="roundRect">
             <a:avLst>
@@ -6406,14 +5485,14 @@
       </p:sp>
       <p:sp>
         <p:nvSpPr>
-          <p:cNvPr id="76" name="TextBox 75"/>
+          <p:cNvPr id="51" name="TextBox 50"/>
           <p:cNvSpPr txBox="1"/>
           <p:nvPr/>
         </p:nvSpPr>
         <p:spPr>
           <a:xfrm>
-            <a:off x="9646920" y="5797296"/>
-            <a:ext cx="914400" cy="182880"/>
+            <a:off x="9326880" y="7095744"/>
+            <a:ext cx="1097280" cy="201168"/>
           </a:xfrm>
           <a:prstGeom prst="rect">
             <a:avLst/>
@@ -6427,7 +5506,7 @@
           <a:lstStyle/>
           <a:p>
             <a:pPr algn="ctr">
-              <a:defRPr sz="1400" b="0">
+              <a:defRPr sz="1500" b="0">
                 <a:solidFill>
                   <a:srgbClr val="53665D"/>
                 </a:solidFill>
@@ -6442,14 +5521,14 @@
       </p:sp>
       <p:sp>
         <p:nvSpPr>
-          <p:cNvPr id="77" name="TextBox 76"/>
+          <p:cNvPr id="52" name="TextBox 51"/>
           <p:cNvSpPr txBox="1"/>
           <p:nvPr/>
         </p:nvSpPr>
         <p:spPr>
           <a:xfrm>
-            <a:off x="9646920" y="6035040"/>
-            <a:ext cx="914400" cy="365760"/>
+            <a:off x="9326880" y="7379208"/>
+            <a:ext cx="1097280" cy="365760"/>
           </a:xfrm>
           <a:prstGeom prst="rect">
             <a:avLst/>
@@ -6463,7 +5542,7 @@
           <a:lstStyle/>
           <a:p>
             <a:pPr algn="ctr">
-              <a:defRPr sz="2900" b="1">
+              <a:defRPr sz="3200" b="1">
                 <a:solidFill>
                   <a:srgbClr val="17382D"/>
                 </a:solidFill>
@@ -6478,14 +5557,14 @@
       </p:sp>
       <p:sp>
         <p:nvSpPr>
-          <p:cNvPr id="78" name="Rounded Rectangle 77"/>
+          <p:cNvPr id="53" name="Rounded Rectangle 52"/>
           <p:cNvSpPr/>
           <p:nvPr/>
         </p:nvSpPr>
         <p:spPr>
           <a:xfrm>
-            <a:off x="11430000" y="4407408"/>
-            <a:ext cx="2377440" cy="804672"/>
+            <a:off x="11155680" y="5102352"/>
+            <a:ext cx="3017520" cy="1051560"/>
           </a:xfrm>
           <a:prstGeom prst="roundRect">
             <a:avLst>
@@ -6525,14 +5604,14 @@
       </p:sp>
       <p:sp>
         <p:nvSpPr>
-          <p:cNvPr id="79" name="TextBox 78"/>
+          <p:cNvPr id="54" name="TextBox 53"/>
           <p:cNvSpPr txBox="1"/>
           <p:nvPr/>
         </p:nvSpPr>
         <p:spPr>
           <a:xfrm>
-            <a:off x="11475720" y="4471416"/>
-            <a:ext cx="2286000" cy="237744"/>
+            <a:off x="11247119" y="5239512"/>
+            <a:ext cx="2834640" cy="292608"/>
           </a:xfrm>
           <a:prstGeom prst="rect">
             <a:avLst/>
@@ -6546,7 +5625,7 @@
           <a:lstStyle/>
           <a:p>
             <a:pPr algn="ctr">
-              <a:defRPr sz="1700" b="1">
+              <a:defRPr sz="2100" b="1">
                 <a:solidFill>
                   <a:srgbClr val="9D3E32"/>
                 </a:solidFill>
@@ -6554,21 +5633,21 @@
               </a:defRPr>
             </a:pPr>
             <a:r>
-              <a:t>After human H2</a:t>
-            </a:r>
-          </a:p>
-        </p:txBody>
-      </p:sp>
-      <p:sp>
-        <p:nvSpPr>
-          <p:cNvPr id="80" name="TextBox 79"/>
+              <a:t>BOT · after H2</a:t>
+            </a:r>
+          </a:p>
+        </p:txBody>
+      </p:sp>
+      <p:sp>
+        <p:nvSpPr>
+          <p:cNvPr id="55" name="TextBox 54"/>
           <p:cNvSpPr txBox="1"/>
           <p:nvPr/>
         </p:nvSpPr>
         <p:spPr>
           <a:xfrm>
-            <a:off x="11475720" y="4800600"/>
-            <a:ext cx="2286000" cy="274320"/>
+            <a:off x="11247119" y="5696712"/>
+            <a:ext cx="2834640" cy="292608"/>
           </a:xfrm>
           <a:prstGeom prst="rect">
             <a:avLst/>
@@ -6582,7 +5661,7 @@
           <a:lstStyle/>
           <a:p>
             <a:pPr algn="ctr">
-              <a:defRPr sz="2000" b="1">
+              <a:defRPr sz="2400" b="1">
                 <a:solidFill>
                   <a:srgbClr val="9D3E32"/>
                 </a:solidFill>
@@ -6597,14 +5676,14 @@
       </p:sp>
       <p:sp>
         <p:nvSpPr>
-          <p:cNvPr id="81" name="Rounded Rectangle 80"/>
+          <p:cNvPr id="56" name="Rounded Rectangle 55"/>
           <p:cNvSpPr/>
           <p:nvPr/>
         </p:nvSpPr>
         <p:spPr>
           <a:xfrm>
-            <a:off x="11521440" y="5742432"/>
-            <a:ext cx="1005840" cy="749808"/>
+            <a:off x="11292840" y="7022592"/>
+            <a:ext cx="1188720" cy="822960"/>
           </a:xfrm>
           <a:prstGeom prst="roundRect">
             <a:avLst>
@@ -6644,14 +5723,14 @@
       </p:sp>
       <p:sp>
         <p:nvSpPr>
-          <p:cNvPr id="82" name="TextBox 81"/>
+          <p:cNvPr id="57" name="TextBox 56"/>
           <p:cNvSpPr txBox="1"/>
           <p:nvPr/>
         </p:nvSpPr>
         <p:spPr>
           <a:xfrm>
-            <a:off x="11567160" y="5797296"/>
-            <a:ext cx="914400" cy="182880"/>
+            <a:off x="11338560" y="7095744"/>
+            <a:ext cx="1097280" cy="201168"/>
           </a:xfrm>
           <a:prstGeom prst="rect">
             <a:avLst/>
@@ -6665,7 +5744,7 @@
           <a:lstStyle/>
           <a:p>
             <a:pPr algn="ctr">
-              <a:defRPr sz="1400" b="0">
+              <a:defRPr sz="1500" b="0">
                 <a:solidFill>
                   <a:srgbClr val="53665D"/>
                 </a:solidFill>
@@ -6680,14 +5759,14 @@
       </p:sp>
       <p:sp>
         <p:nvSpPr>
-          <p:cNvPr id="83" name="TextBox 82"/>
+          <p:cNvPr id="58" name="TextBox 57"/>
           <p:cNvSpPr txBox="1"/>
           <p:nvPr/>
         </p:nvSpPr>
         <p:spPr>
           <a:xfrm>
-            <a:off x="11567160" y="6035040"/>
-            <a:ext cx="914400" cy="365760"/>
+            <a:off x="11338560" y="7379208"/>
+            <a:ext cx="1097280" cy="365760"/>
           </a:xfrm>
           <a:prstGeom prst="rect">
             <a:avLst/>
@@ -6701,7 +5780,7 @@
           <a:lstStyle/>
           <a:p>
             <a:pPr algn="ctr">
-              <a:defRPr sz="2900" b="1">
+              <a:defRPr sz="3200" b="1">
                 <a:solidFill>
                   <a:srgbClr val="17382D"/>
                 </a:solidFill>
@@ -6716,14 +5795,14 @@
       </p:sp>
       <p:sp>
         <p:nvSpPr>
-          <p:cNvPr id="84" name="Rounded Rectangle 83"/>
+          <p:cNvPr id="59" name="Rounded Rectangle 58"/>
           <p:cNvSpPr/>
           <p:nvPr/>
         </p:nvSpPr>
         <p:spPr>
           <a:xfrm>
-            <a:off x="12710160" y="5742432"/>
-            <a:ext cx="1005840" cy="749808"/>
+            <a:off x="12847319" y="7022592"/>
+            <a:ext cx="1188720" cy="822960"/>
           </a:xfrm>
           <a:prstGeom prst="roundRect">
             <a:avLst>
@@ -6763,14 +5842,14 @@
       </p:sp>
       <p:sp>
         <p:nvSpPr>
-          <p:cNvPr id="85" name="TextBox 84"/>
+          <p:cNvPr id="60" name="TextBox 59"/>
           <p:cNvSpPr txBox="1"/>
           <p:nvPr/>
         </p:nvSpPr>
         <p:spPr>
           <a:xfrm>
-            <a:off x="12755880" y="5797296"/>
-            <a:ext cx="914400" cy="182880"/>
+            <a:off x="12893040" y="7095744"/>
+            <a:ext cx="1097280" cy="201168"/>
           </a:xfrm>
           <a:prstGeom prst="rect">
             <a:avLst/>
@@ -6784,7 +5863,7 @@
           <a:lstStyle/>
           <a:p>
             <a:pPr algn="ctr">
-              <a:defRPr sz="1400" b="0">
+              <a:defRPr sz="1500" b="0">
                 <a:solidFill>
                   <a:srgbClr val="53665D"/>
                 </a:solidFill>
@@ -6799,14 +5878,14 @@
       </p:sp>
       <p:sp>
         <p:nvSpPr>
-          <p:cNvPr id="86" name="TextBox 85"/>
+          <p:cNvPr id="61" name="TextBox 60"/>
           <p:cNvSpPr txBox="1"/>
           <p:nvPr/>
         </p:nvSpPr>
         <p:spPr>
           <a:xfrm>
-            <a:off x="12755880" y="6035040"/>
-            <a:ext cx="914400" cy="365760"/>
+            <a:off x="12893040" y="7379208"/>
+            <a:ext cx="1097280" cy="365760"/>
           </a:xfrm>
           <a:prstGeom prst="rect">
             <a:avLst/>
@@ -6820,7 +5899,7 @@
           <a:lstStyle/>
           <a:p>
             <a:pPr algn="ctr">
-              <a:defRPr sz="2900" b="1">
+              <a:defRPr sz="3200" b="1">
                 <a:solidFill>
                   <a:srgbClr val="17382D"/>
                 </a:solidFill>
@@ -6829,125 +5908,6 @@
             </a:pPr>
             <a:r>
               <a:t>0</a:t>
-            </a:r>
-          </a:p>
-        </p:txBody>
-      </p:sp>
-      <p:sp>
-        <p:nvSpPr>
-          <p:cNvPr id="87" name="Rounded Rectangle 86"/>
-          <p:cNvSpPr/>
-          <p:nvPr/>
-        </p:nvSpPr>
-        <p:spPr>
-          <a:xfrm>
-            <a:off x="594360" y="6912864"/>
-            <a:ext cx="13441680" cy="566928"/>
-          </a:xfrm>
-          <a:prstGeom prst="roundRect">
-            <a:avLst>
-              <a:gd name="adj" fmla="val 8000"/>
-            </a:avLst>
-          </a:prstGeom>
-          <a:solidFill>
-            <a:srgbClr val="17382D"/>
-          </a:solidFill>
-          <a:ln w="12700">
-            <a:solidFill>
-              <a:srgbClr val="17382D"/>
-            </a:solidFill>
-          </a:ln>
-        </p:spPr>
-        <p:style>
-          <a:lnRef idx="1">
-            <a:schemeClr val="accent1"/>
-          </a:lnRef>
-          <a:fillRef idx="3">
-            <a:schemeClr val="accent1"/>
-          </a:fillRef>
-          <a:effectRef idx="2">
-            <a:schemeClr val="accent1"/>
-          </a:effectRef>
-          <a:fontRef idx="minor">
-            <a:schemeClr val="lt1"/>
-          </a:fontRef>
-        </p:style>
-        <p:txBody>
-          <a:bodyPr rtlCol="0" anchor="ctr"/>
-          <a:lstStyle/>
-          <a:p>
-            <a:pPr algn="ctr"/>
-          </a:p>
-        </p:txBody>
-      </p:sp>
-      <p:sp>
-        <p:nvSpPr>
-          <p:cNvPr id="88" name="TextBox 87"/>
-          <p:cNvSpPr txBox="1"/>
-          <p:nvPr/>
-        </p:nvSpPr>
-        <p:spPr>
-          <a:xfrm>
-            <a:off x="841248" y="6995160"/>
-            <a:ext cx="12947904" cy="365760"/>
-          </a:xfrm>
-          <a:prstGeom prst="rect">
-            <a:avLst/>
-          </a:prstGeom>
-          <a:noFill/>
-        </p:spPr>
-        <p:txBody>
-          <a:bodyPr wrap="none" lIns="0" rIns="0" tIns="0" bIns="0" anchor="ctr">
-            <a:spAutoFit/>
-          </a:bodyPr>
-          <a:lstStyle/>
-          <a:p>
-            <a:pPr algn="ctr">
-              <a:defRPr sz="2500" b="1">
-                <a:solidFill>
-                  <a:srgbClr val="FFFFFF"/>
-                </a:solidFill>
-                <a:latin typeface="Arial"/>
-              </a:defRPr>
-            </a:pPr>
-            <a:r>
-              <a:t>A returns 3.   B returns 0.   findBestMove() returns A.</a:t>
-            </a:r>
-          </a:p>
-        </p:txBody>
-      </p:sp>
-      <p:sp>
-        <p:nvSpPr>
-          <p:cNvPr id="89" name="TextBox 88"/>
-          <p:cNvSpPr txBox="1"/>
-          <p:nvPr/>
-        </p:nvSpPr>
-        <p:spPr>
-          <a:xfrm>
-            <a:off x="594360" y="7534656"/>
-            <a:ext cx="13441680" cy="210312"/>
-          </a:xfrm>
-          <a:prstGeom prst="rect">
-            <a:avLst/>
-          </a:prstGeom>
-          <a:noFill/>
-        </p:spPr>
-        <p:txBody>
-          <a:bodyPr wrap="none" lIns="0" rIns="0" tIns="0" bIns="0" anchor="ctr">
-            <a:spAutoFit/>
-          </a:bodyPr>
-          <a:lstStyle/>
-          <a:p>
-            <a:pPr algn="ctr">
-              <a:defRPr sz="1500" b="0">
-                <a:solidFill>
-                  <a:srgbClr val="53665D"/>
-                </a:solidFill>
-                <a:latin typeface="Arial"/>
-              </a:defRPr>
-            </a:pPr>
-            <a:r>
-              <a:t>Gold traces the predicted choices: A → H2 → Reply 2. Only the first move A is played now.</a:t>
             </a:r>
           </a:p>
         </p:txBody>
@@ -6986,8 +5946,8 @@
         </p:nvSpPr>
         <p:spPr>
           <a:xfrm>
-            <a:off x="594360" y="210312"/>
-            <a:ext cx="10972800" cy="201168"/>
+            <a:off x="548640" y="329184"/>
+            <a:ext cx="13533120" cy="585216"/>
           </a:xfrm>
           <a:prstGeom prst="rect">
             <a:avLst/>
@@ -7000,209 +5960,30 @@
           </a:bodyPr>
           <a:lstStyle/>
           <a:p>
-            <a:pPr algn="l">
-              <a:defRPr sz="1300" b="1">
-                <a:solidFill>
-                  <a:srgbClr val="245B43"/>
+            <a:pPr algn="ctr">
+              <a:defRPr sz="3400" b="1">
+                <a:solidFill>
+                  <a:srgbClr val="17382D"/>
                 </a:solidFill>
                 <a:latin typeface="Arial"/>
               </a:defRPr>
             </a:pPr>
             <a:r>
-              <a:t>DAMKA  /  HOW THE BOT CHOOSES A MOVE</a:t>
-            </a:r>
-          </a:p>
-        </p:txBody>
-      </p:sp>
-      <p:sp>
-        <p:nvSpPr>
-          <p:cNvPr id="3" name="TextBox 2"/>
-          <p:cNvSpPr txBox="1"/>
-          <p:nvPr/>
-        </p:nvSpPr>
-        <p:spPr>
-          <a:xfrm>
-            <a:off x="594360" y="603504"/>
-            <a:ext cx="13441680" cy="512064"/>
-          </a:xfrm>
-          <a:prstGeom prst="rect">
-            <a:avLst/>
-          </a:prstGeom>
-          <a:noFill/>
-        </p:spPr>
-        <p:txBody>
-          <a:bodyPr wrap="none" lIns="0" rIns="0" tIns="0" bIns="0" anchor="ctr">
-            <a:spAutoFit/>
-          </a:bodyPr>
-          <a:lstStyle/>
-          <a:p>
-            <a:pPr algn="l">
-              <a:defRPr sz="3300" b="1">
-                <a:solidFill>
-                  <a:srgbClr val="17382D"/>
-                </a:solidFill>
-                <a:latin typeface="Arial"/>
-              </a:defRPr>
-            </a:pPr>
-            <a:r>
-              <a:t>The same example, one path per row</a:t>
-            </a:r>
-          </a:p>
-        </p:txBody>
-      </p:sp>
-      <p:sp>
-        <p:nvSpPr>
-          <p:cNvPr id="4" name="TextBox 3"/>
-          <p:cNvSpPr txBox="1"/>
-          <p:nvPr/>
-        </p:nvSpPr>
-        <p:spPr>
-          <a:xfrm>
-            <a:off x="594360" y="1197864"/>
-            <a:ext cx="13441680" cy="329184"/>
-          </a:xfrm>
-          <a:prstGeom prst="rect">
-            <a:avLst/>
-          </a:prstGeom>
-          <a:noFill/>
-        </p:spPr>
-        <p:txBody>
-          <a:bodyPr wrap="none" lIns="0" rIns="0" tIns="0" bIns="0" anchor="ctr">
-            <a:spAutoFit/>
-          </a:bodyPr>
-          <a:lstStyle/>
-          <a:p>
-            <a:pPr algn="l">
-              <a:defRPr sz="1900" b="0">
-                <a:solidFill>
-                  <a:srgbClr val="53665D"/>
-                </a:solidFill>
-                <a:latin typeface="Arial"/>
-              </a:defRPr>
-            </a:pPr>
-            <a:r>
-              <a:t>The score is calculated after the third simulated move. Then MAX and MIN return values upward.</a:t>
-            </a:r>
-          </a:p>
-        </p:txBody>
-      </p:sp>
-      <p:cxnSp>
-        <p:nvCxnSpPr>
-          <p:cNvPr id="5" name="Connector 4"/>
-          <p:cNvCxnSpPr/>
-          <p:nvPr/>
-        </p:nvCxnSpPr>
-        <p:spPr>
-          <a:xfrm>
-            <a:off x="594360" y="1645920"/>
-            <a:ext cx="13441680" cy="0"/>
-          </a:xfrm>
-          <a:prstGeom prst="line">
-            <a:avLst/>
-          </a:prstGeom>
-          <a:ln w="12700">
-            <a:solidFill>
-              <a:srgbClr val="C9D4CC"/>
-            </a:solidFill>
-          </a:ln>
-        </p:spPr>
-        <p:style>
-          <a:lnRef idx="2">
-            <a:schemeClr val="accent1"/>
-          </a:lnRef>
-          <a:fillRef idx="0">
-            <a:schemeClr val="accent1"/>
-          </a:fillRef>
-          <a:effectRef idx="1">
-            <a:schemeClr val="accent1"/>
-          </a:effectRef>
-          <a:fontRef idx="minor">
-            <a:schemeClr val="tx1"/>
-          </a:fontRef>
-        </p:style>
-      </p:cxnSp>
-      <p:sp>
-        <p:nvSpPr>
-          <p:cNvPr id="6" name="TextBox 5"/>
-          <p:cNvSpPr txBox="1"/>
-          <p:nvPr/>
-        </p:nvSpPr>
-        <p:spPr>
-          <a:xfrm>
-            <a:off x="594360" y="7818120"/>
-            <a:ext cx="12527280" cy="201168"/>
-          </a:xfrm>
-          <a:prstGeom prst="rect">
-            <a:avLst/>
-          </a:prstGeom>
-          <a:noFill/>
-        </p:spPr>
-        <p:txBody>
-          <a:bodyPr wrap="none" lIns="0" rIns="0" tIns="0" bIns="0" anchor="ctr">
-            <a:spAutoFit/>
-          </a:bodyPr>
-          <a:lstStyle/>
-          <a:p>
-            <a:pPr algn="l">
-              <a:defRPr sz="1300" b="0">
-                <a:solidFill>
-                  <a:srgbClr val="53665D"/>
-                </a:solidFill>
-                <a:latin typeface="Arial"/>
-              </a:defRPr>
-            </a:pPr>
-            <a:r>
-              <a:t>Illustrative scores; alternating turns and no early winner. Every score is from the BOT’s perspective.</a:t>
-            </a:r>
-          </a:p>
-        </p:txBody>
-      </p:sp>
-      <p:sp>
-        <p:nvSpPr>
-          <p:cNvPr id="7" name="TextBox 6"/>
-          <p:cNvSpPr txBox="1"/>
-          <p:nvPr/>
-        </p:nvSpPr>
-        <p:spPr>
-          <a:xfrm>
-            <a:off x="13167360" y="7799831"/>
-            <a:ext cx="868680" cy="228600"/>
-          </a:xfrm>
-          <a:prstGeom prst="rect">
-            <a:avLst/>
-          </a:prstGeom>
-          <a:noFill/>
-        </p:spPr>
-        <p:txBody>
-          <a:bodyPr wrap="none" lIns="0" rIns="0" tIns="0" bIns="0" anchor="ctr">
-            <a:spAutoFit/>
-          </a:bodyPr>
-          <a:lstStyle/>
-          <a:p>
-            <a:pPr algn="r">
-              <a:defRPr sz="1300" b="0">
-                <a:solidFill>
-                  <a:srgbClr val="53665D"/>
-                </a:solidFill>
-                <a:latin typeface="Arial"/>
-              </a:defRPr>
-            </a:pPr>
-            <a:r>
-              <a:t>02 / 02</a:t>
-            </a:r>
-          </a:p>
-        </p:txBody>
-      </p:sp>
-      <p:sp>
-        <p:nvSpPr>
-          <p:cNvPr id="8" name="Rounded Rectangle 7"/>
+              <a:t>Minimax · Depth 3</a:t>
+            </a:r>
+          </a:p>
+        </p:txBody>
+      </p:sp>
+      <p:sp>
+        <p:nvSpPr>
+          <p:cNvPr id="3" name="Rounded Rectangle 2"/>
           <p:cNvSpPr/>
           <p:nvPr/>
         </p:nvSpPr>
         <p:spPr>
           <a:xfrm>
-            <a:off x="594360" y="1901952"/>
-            <a:ext cx="13441680" cy="640080"/>
+            <a:off x="594360" y="1389888"/>
+            <a:ext cx="13441680" cy="731520"/>
           </a:xfrm>
           <a:prstGeom prst="roundRect">
             <a:avLst>
@@ -7242,13 +6023,13 @@
       </p:sp>
       <p:sp>
         <p:nvSpPr>
-          <p:cNvPr id="9" name="TextBox 8"/>
+          <p:cNvPr id="4" name="TextBox 3"/>
           <p:cNvSpPr txBox="1"/>
           <p:nvPr/>
         </p:nvSpPr>
         <p:spPr>
           <a:xfrm>
-            <a:off x="731520" y="2057400"/>
+            <a:off x="731520" y="1591056"/>
             <a:ext cx="2606040" cy="320040"/>
           </a:xfrm>
           <a:prstGeom prst="rect">
@@ -7278,13 +6059,13 @@
       </p:sp>
       <p:sp>
         <p:nvSpPr>
-          <p:cNvPr id="10" name="TextBox 9"/>
+          <p:cNvPr id="5" name="TextBox 4"/>
           <p:cNvSpPr txBox="1"/>
           <p:nvPr/>
         </p:nvSpPr>
         <p:spPr>
           <a:xfrm>
-            <a:off x="3611879" y="2057400"/>
+            <a:off x="3611879" y="1591056"/>
             <a:ext cx="3063240" cy="320040"/>
           </a:xfrm>
           <a:prstGeom prst="rect">
@@ -7314,13 +6095,13 @@
       </p:sp>
       <p:sp>
         <p:nvSpPr>
-          <p:cNvPr id="11" name="TextBox 10"/>
+          <p:cNvPr id="6" name="TextBox 5"/>
           <p:cNvSpPr txBox="1"/>
           <p:nvPr/>
         </p:nvSpPr>
         <p:spPr>
           <a:xfrm>
-            <a:off x="6949440" y="2057400"/>
+            <a:off x="6949440" y="1591056"/>
             <a:ext cx="3474720" cy="320040"/>
           </a:xfrm>
           <a:prstGeom prst="rect">
@@ -7350,13 +6131,13 @@
       </p:sp>
       <p:sp>
         <p:nvSpPr>
-          <p:cNvPr id="12" name="TextBox 11"/>
+          <p:cNvPr id="7" name="TextBox 6"/>
           <p:cNvSpPr txBox="1"/>
           <p:nvPr/>
         </p:nvSpPr>
         <p:spPr>
           <a:xfrm>
-            <a:off x="10698480" y="2057400"/>
+            <a:off x="10698480" y="1591056"/>
             <a:ext cx="3200399" cy="320040"/>
           </a:xfrm>
           <a:prstGeom prst="rect">
@@ -7386,14 +6167,14 @@
       </p:sp>
       <p:sp>
         <p:nvSpPr>
-          <p:cNvPr id="13" name="Rectangle 12"/>
+          <p:cNvPr id="8" name="Rectangle 7"/>
           <p:cNvSpPr/>
           <p:nvPr/>
         </p:nvSpPr>
         <p:spPr>
           <a:xfrm>
-            <a:off x="594360" y="2542032"/>
-            <a:ext cx="13441680" cy="388620"/>
+            <a:off x="594360" y="2121408"/>
+            <a:ext cx="13441680" cy="457200"/>
           </a:xfrm>
           <a:prstGeom prst="rect">
             <a:avLst/>
@@ -7431,14 +6212,14 @@
       </p:sp>
       <p:sp>
         <p:nvSpPr>
-          <p:cNvPr id="14" name="TextBox 13"/>
+          <p:cNvPr id="9" name="TextBox 8"/>
           <p:cNvSpPr txBox="1"/>
           <p:nvPr/>
         </p:nvSpPr>
         <p:spPr>
           <a:xfrm>
-            <a:off x="731520" y="2578608"/>
-            <a:ext cx="2606040" cy="315468"/>
+            <a:off x="731520" y="2185416"/>
+            <a:ext cx="2606040" cy="329184"/>
           </a:xfrm>
           <a:prstGeom prst="rect">
             <a:avLst/>
@@ -7467,14 +6248,14 @@
       </p:sp>
       <p:sp>
         <p:nvSpPr>
-          <p:cNvPr id="15" name="TextBox 14"/>
+          <p:cNvPr id="10" name="TextBox 9"/>
           <p:cNvSpPr txBox="1"/>
           <p:nvPr/>
         </p:nvSpPr>
         <p:spPr>
           <a:xfrm>
-            <a:off x="3611879" y="2578608"/>
-            <a:ext cx="3063240" cy="315468"/>
+            <a:off x="3611879" y="2185416"/>
+            <a:ext cx="3063240" cy="329184"/>
           </a:xfrm>
           <a:prstGeom prst="rect">
             <a:avLst/>
@@ -7503,14 +6284,14 @@
       </p:sp>
       <p:sp>
         <p:nvSpPr>
-          <p:cNvPr id="16" name="TextBox 15"/>
+          <p:cNvPr id="11" name="TextBox 10"/>
           <p:cNvSpPr txBox="1"/>
           <p:nvPr/>
         </p:nvSpPr>
         <p:spPr>
           <a:xfrm>
-            <a:off x="6949440" y="2578608"/>
-            <a:ext cx="3474720" cy="315468"/>
+            <a:off x="6949440" y="2185416"/>
+            <a:ext cx="3474720" cy="329184"/>
           </a:xfrm>
           <a:prstGeom prst="rect">
             <a:avLst/>
@@ -7539,14 +6320,14 @@
       </p:sp>
       <p:sp>
         <p:nvSpPr>
-          <p:cNvPr id="17" name="TextBox 16"/>
+          <p:cNvPr id="12" name="TextBox 11"/>
           <p:cNvSpPr txBox="1"/>
           <p:nvPr/>
         </p:nvSpPr>
         <p:spPr>
           <a:xfrm>
-            <a:off x="10698480" y="2578608"/>
-            <a:ext cx="3200399" cy="315468"/>
+            <a:off x="10698480" y="2185416"/>
+            <a:ext cx="3200399" cy="329184"/>
           </a:xfrm>
           <a:prstGeom prst="rect">
             <a:avLst/>
@@ -7575,14 +6356,14 @@
       </p:sp>
       <p:sp>
         <p:nvSpPr>
-          <p:cNvPr id="18" name="Rectangle 17"/>
+          <p:cNvPr id="13" name="Rectangle 12"/>
           <p:cNvSpPr/>
           <p:nvPr/>
         </p:nvSpPr>
         <p:spPr>
           <a:xfrm>
-            <a:off x="594360" y="2930652"/>
-            <a:ext cx="13441680" cy="388620"/>
+            <a:off x="594360" y="2578608"/>
+            <a:ext cx="13441680" cy="457200"/>
           </a:xfrm>
           <a:prstGeom prst="rect">
             <a:avLst/>
@@ -7620,14 +6401,14 @@
       </p:sp>
       <p:sp>
         <p:nvSpPr>
-          <p:cNvPr id="19" name="TextBox 18"/>
+          <p:cNvPr id="14" name="TextBox 13"/>
           <p:cNvSpPr txBox="1"/>
           <p:nvPr/>
         </p:nvSpPr>
         <p:spPr>
           <a:xfrm>
-            <a:off x="731520" y="2967228"/>
-            <a:ext cx="2606040" cy="315468"/>
+            <a:off x="731520" y="2642616"/>
+            <a:ext cx="2606040" cy="329184"/>
           </a:xfrm>
           <a:prstGeom prst="rect">
             <a:avLst/>
@@ -7656,14 +6437,14 @@
       </p:sp>
       <p:sp>
         <p:nvSpPr>
-          <p:cNvPr id="20" name="TextBox 19"/>
+          <p:cNvPr id="15" name="TextBox 14"/>
           <p:cNvSpPr txBox="1"/>
           <p:nvPr/>
         </p:nvSpPr>
         <p:spPr>
           <a:xfrm>
-            <a:off x="3611879" y="2967228"/>
-            <a:ext cx="3063240" cy="315468"/>
+            <a:off x="3611879" y="2642616"/>
+            <a:ext cx="3063240" cy="329184"/>
           </a:xfrm>
           <a:prstGeom prst="rect">
             <a:avLst/>
@@ -7692,14 +6473,14 @@
       </p:sp>
       <p:sp>
         <p:nvSpPr>
-          <p:cNvPr id="21" name="TextBox 20"/>
+          <p:cNvPr id="16" name="TextBox 15"/>
           <p:cNvSpPr txBox="1"/>
           <p:nvPr/>
         </p:nvSpPr>
         <p:spPr>
           <a:xfrm>
-            <a:off x="6949440" y="2967228"/>
-            <a:ext cx="3474720" cy="315468"/>
+            <a:off x="6949440" y="2642616"/>
+            <a:ext cx="3474720" cy="329184"/>
           </a:xfrm>
           <a:prstGeom prst="rect">
             <a:avLst/>
@@ -7728,14 +6509,14 @@
       </p:sp>
       <p:sp>
         <p:nvSpPr>
-          <p:cNvPr id="22" name="TextBox 21"/>
+          <p:cNvPr id="17" name="TextBox 16"/>
           <p:cNvSpPr txBox="1"/>
           <p:nvPr/>
         </p:nvSpPr>
         <p:spPr>
           <a:xfrm>
-            <a:off x="10698480" y="2967228"/>
-            <a:ext cx="3200399" cy="315468"/>
+            <a:off x="10698480" y="2642616"/>
+            <a:ext cx="3200399" cy="329184"/>
           </a:xfrm>
           <a:prstGeom prst="rect">
             <a:avLst/>
@@ -7764,14 +6545,14 @@
       </p:sp>
       <p:sp>
         <p:nvSpPr>
-          <p:cNvPr id="23" name="Rectangle 22"/>
+          <p:cNvPr id="18" name="Rectangle 17"/>
           <p:cNvSpPr/>
           <p:nvPr/>
         </p:nvSpPr>
         <p:spPr>
           <a:xfrm>
-            <a:off x="594360" y="3319272"/>
-            <a:ext cx="13441680" cy="388620"/>
+            <a:off x="594360" y="3035808"/>
+            <a:ext cx="13441680" cy="457200"/>
           </a:xfrm>
           <a:prstGeom prst="rect">
             <a:avLst/>
@@ -7809,14 +6590,14 @@
       </p:sp>
       <p:sp>
         <p:nvSpPr>
-          <p:cNvPr id="24" name="TextBox 23"/>
+          <p:cNvPr id="19" name="TextBox 18"/>
           <p:cNvSpPr txBox="1"/>
           <p:nvPr/>
         </p:nvSpPr>
         <p:spPr>
           <a:xfrm>
-            <a:off x="731520" y="3355848"/>
-            <a:ext cx="2606040" cy="315468"/>
+            <a:off x="731520" y="3099816"/>
+            <a:ext cx="2606040" cy="329184"/>
           </a:xfrm>
           <a:prstGeom prst="rect">
             <a:avLst/>
@@ -7845,14 +6626,14 @@
       </p:sp>
       <p:sp>
         <p:nvSpPr>
-          <p:cNvPr id="25" name="TextBox 24"/>
+          <p:cNvPr id="20" name="TextBox 19"/>
           <p:cNvSpPr txBox="1"/>
           <p:nvPr/>
         </p:nvSpPr>
         <p:spPr>
           <a:xfrm>
-            <a:off x="3611879" y="3355848"/>
-            <a:ext cx="3063240" cy="315468"/>
+            <a:off x="3611879" y="3099816"/>
+            <a:ext cx="3063240" cy="329184"/>
           </a:xfrm>
           <a:prstGeom prst="rect">
             <a:avLst/>
@@ -7881,14 +6662,14 @@
       </p:sp>
       <p:sp>
         <p:nvSpPr>
-          <p:cNvPr id="26" name="TextBox 25"/>
+          <p:cNvPr id="21" name="TextBox 20"/>
           <p:cNvSpPr txBox="1"/>
           <p:nvPr/>
         </p:nvSpPr>
         <p:spPr>
           <a:xfrm>
-            <a:off x="6949440" y="3355848"/>
-            <a:ext cx="3474720" cy="315468"/>
+            <a:off x="6949440" y="3099816"/>
+            <a:ext cx="3474720" cy="329184"/>
           </a:xfrm>
           <a:prstGeom prst="rect">
             <a:avLst/>
@@ -7917,14 +6698,14 @@
       </p:sp>
       <p:sp>
         <p:nvSpPr>
-          <p:cNvPr id="27" name="TextBox 26"/>
+          <p:cNvPr id="22" name="TextBox 21"/>
           <p:cNvSpPr txBox="1"/>
           <p:nvPr/>
         </p:nvSpPr>
         <p:spPr>
           <a:xfrm>
-            <a:off x="10698480" y="3355848"/>
-            <a:ext cx="3200399" cy="315468"/>
+            <a:off x="10698480" y="3099816"/>
+            <a:ext cx="3200399" cy="329184"/>
           </a:xfrm>
           <a:prstGeom prst="rect">
             <a:avLst/>
@@ -7953,14 +6734,14 @@
       </p:sp>
       <p:sp>
         <p:nvSpPr>
-          <p:cNvPr id="28" name="Rectangle 27"/>
+          <p:cNvPr id="23" name="Rectangle 22"/>
           <p:cNvSpPr/>
           <p:nvPr/>
         </p:nvSpPr>
         <p:spPr>
           <a:xfrm>
-            <a:off x="594360" y="3707891"/>
-            <a:ext cx="13441680" cy="388620"/>
+            <a:off x="594360" y="3493008"/>
+            <a:ext cx="13441680" cy="457200"/>
           </a:xfrm>
           <a:prstGeom prst="rect">
             <a:avLst/>
@@ -7998,14 +6779,14 @@
       </p:sp>
       <p:sp>
         <p:nvSpPr>
-          <p:cNvPr id="29" name="TextBox 28"/>
+          <p:cNvPr id="24" name="TextBox 23"/>
           <p:cNvSpPr txBox="1"/>
           <p:nvPr/>
         </p:nvSpPr>
         <p:spPr>
           <a:xfrm>
-            <a:off x="731520" y="3744468"/>
-            <a:ext cx="2606040" cy="315468"/>
+            <a:off x="731520" y="3557016"/>
+            <a:ext cx="2606040" cy="329184"/>
           </a:xfrm>
           <a:prstGeom prst="rect">
             <a:avLst/>
@@ -8034,14 +6815,14 @@
       </p:sp>
       <p:sp>
         <p:nvSpPr>
-          <p:cNvPr id="30" name="TextBox 29"/>
+          <p:cNvPr id="25" name="TextBox 24"/>
           <p:cNvSpPr txBox="1"/>
           <p:nvPr/>
         </p:nvSpPr>
         <p:spPr>
           <a:xfrm>
-            <a:off x="3611879" y="3744468"/>
-            <a:ext cx="3063240" cy="315468"/>
+            <a:off x="3611879" y="3557016"/>
+            <a:ext cx="3063240" cy="329184"/>
           </a:xfrm>
           <a:prstGeom prst="rect">
             <a:avLst/>
@@ -8070,14 +6851,14 @@
       </p:sp>
       <p:sp>
         <p:nvSpPr>
-          <p:cNvPr id="31" name="TextBox 30"/>
+          <p:cNvPr id="26" name="TextBox 25"/>
           <p:cNvSpPr txBox="1"/>
           <p:nvPr/>
         </p:nvSpPr>
         <p:spPr>
           <a:xfrm>
-            <a:off x="6949440" y="3744468"/>
-            <a:ext cx="3474720" cy="315468"/>
+            <a:off x="6949440" y="3557016"/>
+            <a:ext cx="3474720" cy="329184"/>
           </a:xfrm>
           <a:prstGeom prst="rect">
             <a:avLst/>
@@ -8106,14 +6887,14 @@
       </p:sp>
       <p:sp>
         <p:nvSpPr>
-          <p:cNvPr id="32" name="TextBox 31"/>
+          <p:cNvPr id="27" name="TextBox 26"/>
           <p:cNvSpPr txBox="1"/>
           <p:nvPr/>
         </p:nvSpPr>
         <p:spPr>
           <a:xfrm>
-            <a:off x="10698480" y="3744468"/>
-            <a:ext cx="3200399" cy="315468"/>
+            <a:off x="10698480" y="3557016"/>
+            <a:ext cx="3200399" cy="329184"/>
           </a:xfrm>
           <a:prstGeom prst="rect">
             <a:avLst/>
@@ -8142,14 +6923,14 @@
       </p:sp>
       <p:sp>
         <p:nvSpPr>
-          <p:cNvPr id="33" name="Rectangle 32"/>
+          <p:cNvPr id="28" name="Rectangle 27"/>
           <p:cNvSpPr/>
           <p:nvPr/>
         </p:nvSpPr>
         <p:spPr>
           <a:xfrm>
-            <a:off x="594360" y="4096512"/>
-            <a:ext cx="13441680" cy="388620"/>
+            <a:off x="594360" y="3950208"/>
+            <a:ext cx="13441680" cy="457200"/>
           </a:xfrm>
           <a:prstGeom prst="rect">
             <a:avLst/>
@@ -8187,14 +6968,14 @@
       </p:sp>
       <p:sp>
         <p:nvSpPr>
-          <p:cNvPr id="34" name="TextBox 33"/>
+          <p:cNvPr id="29" name="TextBox 28"/>
           <p:cNvSpPr txBox="1"/>
           <p:nvPr/>
         </p:nvSpPr>
         <p:spPr>
           <a:xfrm>
-            <a:off x="731520" y="4133088"/>
-            <a:ext cx="2606040" cy="315468"/>
+            <a:off x="731520" y="4014216"/>
+            <a:ext cx="2606040" cy="329184"/>
           </a:xfrm>
           <a:prstGeom prst="rect">
             <a:avLst/>
@@ -8223,14 +7004,14 @@
       </p:sp>
       <p:sp>
         <p:nvSpPr>
-          <p:cNvPr id="35" name="TextBox 34"/>
+          <p:cNvPr id="30" name="TextBox 29"/>
           <p:cNvSpPr txBox="1"/>
           <p:nvPr/>
         </p:nvSpPr>
         <p:spPr>
           <a:xfrm>
-            <a:off x="3611879" y="4133088"/>
-            <a:ext cx="3063240" cy="315468"/>
+            <a:off x="3611879" y="4014216"/>
+            <a:ext cx="3063240" cy="329184"/>
           </a:xfrm>
           <a:prstGeom prst="rect">
             <a:avLst/>
@@ -8259,14 +7040,14 @@
       </p:sp>
       <p:sp>
         <p:nvSpPr>
-          <p:cNvPr id="36" name="TextBox 35"/>
+          <p:cNvPr id="31" name="TextBox 30"/>
           <p:cNvSpPr txBox="1"/>
           <p:nvPr/>
         </p:nvSpPr>
         <p:spPr>
           <a:xfrm>
-            <a:off x="6949440" y="4133088"/>
-            <a:ext cx="3474720" cy="315468"/>
+            <a:off x="6949440" y="4014216"/>
+            <a:ext cx="3474720" cy="329184"/>
           </a:xfrm>
           <a:prstGeom prst="rect">
             <a:avLst/>
@@ -8295,14 +7076,14 @@
       </p:sp>
       <p:sp>
         <p:nvSpPr>
-          <p:cNvPr id="37" name="TextBox 36"/>
+          <p:cNvPr id="32" name="TextBox 31"/>
           <p:cNvSpPr txBox="1"/>
           <p:nvPr/>
         </p:nvSpPr>
         <p:spPr>
           <a:xfrm>
-            <a:off x="10698480" y="4133088"/>
-            <a:ext cx="3200399" cy="315468"/>
+            <a:off x="10698480" y="4014216"/>
+            <a:ext cx="3200399" cy="329184"/>
           </a:xfrm>
           <a:prstGeom prst="rect">
             <a:avLst/>
@@ -8331,14 +7112,14 @@
       </p:sp>
       <p:sp>
         <p:nvSpPr>
-          <p:cNvPr id="38" name="Rectangle 37"/>
+          <p:cNvPr id="33" name="Rectangle 32"/>
           <p:cNvSpPr/>
           <p:nvPr/>
         </p:nvSpPr>
         <p:spPr>
           <a:xfrm>
-            <a:off x="594360" y="4485132"/>
-            <a:ext cx="13441680" cy="388620"/>
+            <a:off x="594360" y="4407408"/>
+            <a:ext cx="13441680" cy="457200"/>
           </a:xfrm>
           <a:prstGeom prst="rect">
             <a:avLst/>
@@ -8376,14 +7157,14 @@
       </p:sp>
       <p:sp>
         <p:nvSpPr>
-          <p:cNvPr id="39" name="TextBox 38"/>
+          <p:cNvPr id="34" name="TextBox 33"/>
           <p:cNvSpPr txBox="1"/>
           <p:nvPr/>
         </p:nvSpPr>
         <p:spPr>
           <a:xfrm>
-            <a:off x="731520" y="4521708"/>
-            <a:ext cx="2606040" cy="315468"/>
+            <a:off x="731520" y="4471416"/>
+            <a:ext cx="2606040" cy="329184"/>
           </a:xfrm>
           <a:prstGeom prst="rect">
             <a:avLst/>
@@ -8412,14 +7193,14 @@
       </p:sp>
       <p:sp>
         <p:nvSpPr>
-          <p:cNvPr id="40" name="TextBox 39"/>
+          <p:cNvPr id="35" name="TextBox 34"/>
           <p:cNvSpPr txBox="1"/>
           <p:nvPr/>
         </p:nvSpPr>
         <p:spPr>
           <a:xfrm>
-            <a:off x="3611879" y="4521708"/>
-            <a:ext cx="3063240" cy="315468"/>
+            <a:off x="3611879" y="4471416"/>
+            <a:ext cx="3063240" cy="329184"/>
           </a:xfrm>
           <a:prstGeom prst="rect">
             <a:avLst/>
@@ -8448,14 +7229,14 @@
       </p:sp>
       <p:sp>
         <p:nvSpPr>
-          <p:cNvPr id="41" name="TextBox 40"/>
+          <p:cNvPr id="36" name="TextBox 35"/>
           <p:cNvSpPr txBox="1"/>
           <p:nvPr/>
         </p:nvSpPr>
         <p:spPr>
           <a:xfrm>
-            <a:off x="6949440" y="4521708"/>
-            <a:ext cx="3474720" cy="315468"/>
+            <a:off x="6949440" y="4471416"/>
+            <a:ext cx="3474720" cy="329184"/>
           </a:xfrm>
           <a:prstGeom prst="rect">
             <a:avLst/>
@@ -8484,14 +7265,14 @@
       </p:sp>
       <p:sp>
         <p:nvSpPr>
-          <p:cNvPr id="42" name="TextBox 41"/>
+          <p:cNvPr id="37" name="TextBox 36"/>
           <p:cNvSpPr txBox="1"/>
           <p:nvPr/>
         </p:nvSpPr>
         <p:spPr>
           <a:xfrm>
-            <a:off x="10698480" y="4521708"/>
-            <a:ext cx="3200399" cy="315468"/>
+            <a:off x="10698480" y="4471416"/>
+            <a:ext cx="3200399" cy="329184"/>
           </a:xfrm>
           <a:prstGeom prst="rect">
             <a:avLst/>
@@ -8520,14 +7301,14 @@
       </p:sp>
       <p:sp>
         <p:nvSpPr>
-          <p:cNvPr id="43" name="Rectangle 42"/>
+          <p:cNvPr id="38" name="Rectangle 37"/>
           <p:cNvSpPr/>
           <p:nvPr/>
         </p:nvSpPr>
         <p:spPr>
           <a:xfrm>
-            <a:off x="594360" y="4873752"/>
-            <a:ext cx="13441680" cy="388620"/>
+            <a:off x="594360" y="4864608"/>
+            <a:ext cx="13441680" cy="457200"/>
           </a:xfrm>
           <a:prstGeom prst="rect">
             <a:avLst/>
@@ -8565,14 +7346,14 @@
       </p:sp>
       <p:sp>
         <p:nvSpPr>
-          <p:cNvPr id="44" name="TextBox 43"/>
+          <p:cNvPr id="39" name="TextBox 38"/>
           <p:cNvSpPr txBox="1"/>
           <p:nvPr/>
         </p:nvSpPr>
         <p:spPr>
           <a:xfrm>
-            <a:off x="731520" y="4910328"/>
-            <a:ext cx="2606040" cy="315468"/>
+            <a:off x="731520" y="4928616"/>
+            <a:ext cx="2606040" cy="329184"/>
           </a:xfrm>
           <a:prstGeom prst="rect">
             <a:avLst/>
@@ -8601,14 +7382,14 @@
       </p:sp>
       <p:sp>
         <p:nvSpPr>
-          <p:cNvPr id="45" name="TextBox 44"/>
+          <p:cNvPr id="40" name="TextBox 39"/>
           <p:cNvSpPr txBox="1"/>
           <p:nvPr/>
         </p:nvSpPr>
         <p:spPr>
           <a:xfrm>
-            <a:off x="3611879" y="4910328"/>
-            <a:ext cx="3063240" cy="315468"/>
+            <a:off x="3611879" y="4928616"/>
+            <a:ext cx="3063240" cy="329184"/>
           </a:xfrm>
           <a:prstGeom prst="rect">
             <a:avLst/>
@@ -8637,14 +7418,14 @@
       </p:sp>
       <p:sp>
         <p:nvSpPr>
-          <p:cNvPr id="46" name="TextBox 45"/>
+          <p:cNvPr id="41" name="TextBox 40"/>
           <p:cNvSpPr txBox="1"/>
           <p:nvPr/>
         </p:nvSpPr>
         <p:spPr>
           <a:xfrm>
-            <a:off x="6949440" y="4910328"/>
-            <a:ext cx="3474720" cy="315468"/>
+            <a:off x="6949440" y="4928616"/>
+            <a:ext cx="3474720" cy="329184"/>
           </a:xfrm>
           <a:prstGeom prst="rect">
             <a:avLst/>
@@ -8673,14 +7454,14 @@
       </p:sp>
       <p:sp>
         <p:nvSpPr>
-          <p:cNvPr id="47" name="TextBox 46"/>
+          <p:cNvPr id="42" name="TextBox 41"/>
           <p:cNvSpPr txBox="1"/>
           <p:nvPr/>
         </p:nvSpPr>
         <p:spPr>
           <a:xfrm>
-            <a:off x="10698480" y="4910328"/>
-            <a:ext cx="3200399" cy="315468"/>
+            <a:off x="10698480" y="4928616"/>
+            <a:ext cx="3200399" cy="329184"/>
           </a:xfrm>
           <a:prstGeom prst="rect">
             <a:avLst/>
@@ -8709,14 +7490,14 @@
       </p:sp>
       <p:sp>
         <p:nvSpPr>
-          <p:cNvPr id="48" name="Rectangle 47"/>
+          <p:cNvPr id="43" name="Rectangle 42"/>
           <p:cNvSpPr/>
           <p:nvPr/>
         </p:nvSpPr>
         <p:spPr>
           <a:xfrm>
-            <a:off x="594360" y="5262372"/>
-            <a:ext cx="13441680" cy="388620"/>
+            <a:off x="594360" y="5321808"/>
+            <a:ext cx="13441680" cy="457200"/>
           </a:xfrm>
           <a:prstGeom prst="rect">
             <a:avLst/>
@@ -8754,14 +7535,14 @@
       </p:sp>
       <p:sp>
         <p:nvSpPr>
-          <p:cNvPr id="49" name="TextBox 48"/>
+          <p:cNvPr id="44" name="TextBox 43"/>
           <p:cNvSpPr txBox="1"/>
           <p:nvPr/>
         </p:nvSpPr>
         <p:spPr>
           <a:xfrm>
-            <a:off x="731520" y="5298948"/>
-            <a:ext cx="2606040" cy="315468"/>
+            <a:off x="731520" y="5385816"/>
+            <a:ext cx="2606040" cy="329184"/>
           </a:xfrm>
           <a:prstGeom prst="rect">
             <a:avLst/>
@@ -8790,14 +7571,14 @@
       </p:sp>
       <p:sp>
         <p:nvSpPr>
-          <p:cNvPr id="50" name="TextBox 49"/>
+          <p:cNvPr id="45" name="TextBox 44"/>
           <p:cNvSpPr txBox="1"/>
           <p:nvPr/>
         </p:nvSpPr>
         <p:spPr>
           <a:xfrm>
-            <a:off x="3611879" y="5298948"/>
-            <a:ext cx="3063240" cy="315468"/>
+            <a:off x="3611879" y="5385816"/>
+            <a:ext cx="3063240" cy="329184"/>
           </a:xfrm>
           <a:prstGeom prst="rect">
             <a:avLst/>
@@ -8826,14 +7607,14 @@
       </p:sp>
       <p:sp>
         <p:nvSpPr>
-          <p:cNvPr id="51" name="TextBox 50"/>
+          <p:cNvPr id="46" name="TextBox 45"/>
           <p:cNvSpPr txBox="1"/>
           <p:nvPr/>
         </p:nvSpPr>
         <p:spPr>
           <a:xfrm>
-            <a:off x="6949440" y="5298948"/>
-            <a:ext cx="3474720" cy="315468"/>
+            <a:off x="6949440" y="5385816"/>
+            <a:ext cx="3474720" cy="329184"/>
           </a:xfrm>
           <a:prstGeom prst="rect">
             <a:avLst/>
@@ -8862,14 +7643,14 @@
       </p:sp>
       <p:sp>
         <p:nvSpPr>
-          <p:cNvPr id="52" name="TextBox 51"/>
+          <p:cNvPr id="47" name="TextBox 46"/>
           <p:cNvSpPr txBox="1"/>
           <p:nvPr/>
         </p:nvSpPr>
         <p:spPr>
           <a:xfrm>
-            <a:off x="10698480" y="5298948"/>
-            <a:ext cx="3200399" cy="315468"/>
+            <a:off x="10698480" y="5385816"/>
+            <a:ext cx="3200399" cy="329184"/>
           </a:xfrm>
           <a:prstGeom prst="rect">
             <a:avLst/>
@@ -8898,14 +7679,14 @@
       </p:sp>
       <p:sp>
         <p:nvSpPr>
-          <p:cNvPr id="53" name="Rounded Rectangle 52"/>
+          <p:cNvPr id="48" name="Rounded Rectangle 47"/>
           <p:cNvSpPr/>
           <p:nvPr/>
         </p:nvSpPr>
         <p:spPr>
           <a:xfrm>
-            <a:off x="594360" y="5971032"/>
-            <a:ext cx="6601968" cy="868680"/>
+            <a:off x="594360" y="6172200"/>
+            <a:ext cx="6601968" cy="914400"/>
           </a:xfrm>
           <a:prstGeom prst="roundRect">
             <a:avLst>
@@ -8945,13 +7726,13 @@
       </p:sp>
       <p:sp>
         <p:nvSpPr>
-          <p:cNvPr id="54" name="TextBox 53"/>
+          <p:cNvPr id="49" name="TextBox 48"/>
           <p:cNvSpPr txBox="1"/>
           <p:nvPr/>
         </p:nvSpPr>
         <p:spPr>
           <a:xfrm>
-            <a:off x="731520" y="6071616"/>
+            <a:off x="731520" y="6309360"/>
             <a:ext cx="6327648" cy="274320"/>
           </a:xfrm>
           <a:prstGeom prst="rect">
@@ -8981,13 +7762,13 @@
       </p:sp>
       <p:sp>
         <p:nvSpPr>
-          <p:cNvPr id="55" name="TextBox 54"/>
+          <p:cNvPr id="50" name="TextBox 49"/>
           <p:cNvSpPr txBox="1"/>
           <p:nvPr/>
         </p:nvSpPr>
         <p:spPr>
           <a:xfrm>
-            <a:off x="731520" y="6428232"/>
+            <a:off x="731520" y="6665976"/>
             <a:ext cx="6327648" cy="237744"/>
           </a:xfrm>
           <a:prstGeom prst="rect">
@@ -9017,14 +7798,14 @@
       </p:sp>
       <p:sp>
         <p:nvSpPr>
-          <p:cNvPr id="56" name="Rounded Rectangle 55"/>
+          <p:cNvPr id="51" name="Rounded Rectangle 50"/>
           <p:cNvSpPr/>
           <p:nvPr/>
         </p:nvSpPr>
         <p:spPr>
           <a:xfrm>
-            <a:off x="7434072" y="5971032"/>
-            <a:ext cx="6601968" cy="868680"/>
+            <a:off x="7434072" y="6172200"/>
+            <a:ext cx="6601968" cy="914400"/>
           </a:xfrm>
           <a:prstGeom prst="roundRect">
             <a:avLst>
@@ -9064,13 +7845,13 @@
       </p:sp>
       <p:sp>
         <p:nvSpPr>
-          <p:cNvPr id="57" name="TextBox 56"/>
+          <p:cNvPr id="52" name="TextBox 51"/>
           <p:cNvSpPr txBox="1"/>
           <p:nvPr/>
         </p:nvSpPr>
         <p:spPr>
           <a:xfrm>
-            <a:off x="7571232" y="6071616"/>
+            <a:off x="7571232" y="6309360"/>
             <a:ext cx="6327648" cy="274320"/>
           </a:xfrm>
           <a:prstGeom prst="rect">
@@ -9100,13 +7881,13 @@
       </p:sp>
       <p:sp>
         <p:nvSpPr>
-          <p:cNvPr id="58" name="TextBox 57"/>
+          <p:cNvPr id="53" name="TextBox 52"/>
           <p:cNvSpPr txBox="1"/>
           <p:nvPr/>
         </p:nvSpPr>
         <p:spPr>
           <a:xfrm>
-            <a:off x="7571232" y="6428232"/>
+            <a:off x="7571232" y="6665976"/>
             <a:ext cx="6327648" cy="237744"/>
           </a:xfrm>
           <a:prstGeom prst="rect">
@@ -9136,13 +7917,13 @@
       </p:sp>
       <p:sp>
         <p:nvSpPr>
-          <p:cNvPr id="59" name="TextBox 58"/>
+          <p:cNvPr id="54" name="TextBox 53"/>
           <p:cNvSpPr txBox="1"/>
           <p:nvPr/>
         </p:nvSpPr>
         <p:spPr>
           <a:xfrm>
-            <a:off x="594360" y="7132320"/>
+            <a:off x="594360" y="7434072"/>
             <a:ext cx="13441680" cy="393192"/>
           </a:xfrm>
           <a:prstGeom prst="rect">
@@ -9165,7 +7946,7 @@
               </a:defRPr>
             </a:pPr>
             <a:r>
-              <a:t>findBestMove(): MAX(3, 0) = 3  →  choose A</a:t>
+              <a:t>MAX(3, 0) = 3  →  choose A</a:t>
             </a:r>
           </a:p>
         </p:txBody>

</xml_diff>